<commit_message>
Fix issues in setup aside
</commit_message>
<xml_diff>
--- a/docs/presentations/v3/aside-setup.pptx
+++ b/docs/presentations/v3/aside-setup.pptx
@@ -4,6 +4,9 @@
   <p:sldMasterIdLst>
     <p:sldMasterId id="2147483648" r:id="rId1"/>
   </p:sldMasterIdLst>
+  <p:notesMasterIdLst>
+    <p:notesMasterId r:id="rId15"/>
+  </p:notesMasterIdLst>
   <p:sldIdLst>
     <p:sldId id="256" r:id="rId2"/>
     <p:sldId id="257" r:id="rId3"/>
@@ -19,11 +22,8 @@
     <p:sldId id="267" r:id="rId13"/>
     <p:sldId id="268" r:id="rId14"/>
   </p:sldIdLst>
-  <p:notesMasterIdLst>
-    <p:notesMasterId r:id="rId15"/>
-  </p:notesMasterIdLst>
-  <p:sldSz cx="12191695" cy="6858000"/>
-  <p:notesSz cx="6858000" cy="12191695"/>
+  <p:sldSz cx="12192000" cy="6858000"/>
+  <p:notesSz cx="6858000" cy="12192000"/>
   <p:defaultTextStyle>
     <a:lvl1pPr marL="0" algn="l" defTabSz="914400" rtl="0" eaLnBrk="1" latinLnBrk="0" hangingPunct="1">
       <a:defRPr sz="1800" kern="1200">
@@ -116,6 +116,11 @@
       </a:defRPr>
     </a:lvl9pPr>
   </p:defaultTextStyle>
+  <p:extLst>
+    <p:ext uri="{EFAFB233-063F-42B5-8137-9DF3F51BA10A}">
+      <p15:sldGuideLst xmlns:p15="http://schemas.microsoft.com/office/powerpoint/2012/main"/>
+    </p:ext>
+  </p:extLst>
 </p:presentation>
 </file>
 
@@ -141,234 +146,10 @@
           <a:chExt cx="0" cy="0"/>
         </a:xfrm>
       </p:grpSpPr>
-      <p:sp>
-        <p:nvSpPr>
-          <p:cNvPr id="2" name="Header Placeholder 1"/>
-          <p:cNvSpPr>
-            <a:spLocks noGrp="1"/>
-          </p:cNvSpPr>
-          <p:nvPr>
-            <p:ph type="hdr" sz="quarter"/>
-          </p:nvPr>
-        </p:nvSpPr>
-        <p:spPr>
-          <a:xfrm>
-            <a:off x="0" y="0"/>
-            <a:ext cx="2971800" cy="458788"/>
-          </a:xfrm>
-          <a:prstGeom prst="rect">
-            <a:avLst/>
-          </a:prstGeom>
-        </p:spPr>
-        <p:txBody>
-          <a:bodyPr vert="horz" lIns="91440" tIns="45720" rIns="91440" bIns="45720" rtlCol="0"/>
-          <a:lstStyle>
-            <a:lvl1pPr algn="l">
-              <a:defRPr sz="1200"/>
-            </a:lvl1pPr>
-          </a:lstStyle>
-          <a:p>
-            <a:endParaRPr lang="en-US"/>
-          </a:p>
-        </p:txBody>
-      </p:sp>
-      <p:sp>
-        <p:nvSpPr>
-          <p:cNvPr id="3" name="Date Placeholder 2"/>
-          <p:cNvSpPr>
-            <a:spLocks noGrp="1"/>
-          </p:cNvSpPr>
-          <p:nvPr>
-            <p:ph type="dt" idx="1"/>
-          </p:nvPr>
-        </p:nvSpPr>
-        <p:spPr>
-          <a:xfrm>
-            <a:off x="3884613" y="0"/>
-            <a:ext cx="2971800" cy="458788"/>
-          </a:xfrm>
-          <a:prstGeom prst="rect">
-            <a:avLst/>
-          </a:prstGeom>
-        </p:spPr>
-        <p:txBody>
-          <a:bodyPr vert="horz" lIns="91440" tIns="45720" rIns="91440" bIns="45720" rtlCol="0"/>
-          <a:lstStyle>
-            <a:lvl1pPr algn="r">
-              <a:defRPr sz="1200"/>
-            </a:lvl1pPr>
-          </a:lstStyle>
-          <a:p>
-            <a:fld id="{5282F153-3F37-0F45-9E97-73ACFA13230C}" type="datetimeFigureOut">
-              <a:rPr lang="en-US"/>
-              <a:t>7/23/19</a:t>
-            </a:fld>
-            <a:endParaRPr lang="en-US"/>
-          </a:p>
-        </p:txBody>
-      </p:sp>
-      <p:sp>
-        <p:nvSpPr>
-          <p:cNvPr id="4" name="Slide Image Placeholder 3"/>
-          <p:cNvSpPr>
-            <a:spLocks noGrp="1" noRot="1" noChangeAspect="1"/>
-          </p:cNvSpPr>
-          <p:nvPr>
-            <p:ph type="sldImg" idx="2"/>
-          </p:nvPr>
-        </p:nvSpPr>
-        <p:spPr>
-          <a:xfrm>
-            <a:off x="685800" y="1143000"/>
-            <a:ext cx="5486400" cy="3086100"/>
-          </a:xfrm>
-          <a:prstGeom prst="rect">
-            <a:avLst/>
-          </a:prstGeom>
-          <a:noFill/>
-          <a:ln w="12700">
-            <a:solidFill>
-              <a:prstClr val="black"/>
-            </a:solidFill>
-          </a:ln>
-        </p:spPr>
-        <p:txBody>
-          <a:bodyPr vert="horz" lIns="91440" tIns="45720" rIns="91440" bIns="45720" rtlCol="0" anchor="ctr"/>
-          <a:lstStyle/>
-          <a:p>
-            <a:endParaRPr lang="en-US"/>
-          </a:p>
-        </p:txBody>
-      </p:sp>
-      <p:sp>
-        <p:nvSpPr>
-          <p:cNvPr id="5" name="Notes Placeholder 4"/>
-          <p:cNvSpPr>
-            <a:spLocks noGrp="1"/>
-          </p:cNvSpPr>
-          <p:nvPr>
-            <p:ph type="body" sz="quarter" idx="3"/>
-          </p:nvPr>
-        </p:nvSpPr>
-        <p:spPr>
-          <a:xfrm>
-            <a:off x="685800" y="4400550"/>
-            <a:ext cx="5486400" cy="3600450"/>
-          </a:xfrm>
-          <a:prstGeom prst="rect">
-            <a:avLst/>
-          </a:prstGeom>
-        </p:spPr>
-        <p:txBody>
-          <a:bodyPr vert="horz" lIns="91440" tIns="45720" rIns="91440" bIns="45720" rtlCol="0"/>
-          <a:lstStyle/>
-          <a:p>
-            <a:pPr lvl="0"/>
-            <a:r>
-              <a:rPr lang="en-US"/>
-              <a:t>Click to edit Master text styles</a:t>
-            </a:r>
-          </a:p>
-          <a:p>
-            <a:pPr lvl="1"/>
-            <a:r>
-              <a:rPr lang="en-US"/>
-              <a:t>Second level</a:t>
-            </a:r>
-          </a:p>
-          <a:p>
-            <a:pPr lvl="2"/>
-            <a:r>
-              <a:rPr lang="en-US"/>
-              <a:t>Third level</a:t>
-            </a:r>
-          </a:p>
-          <a:p>
-            <a:pPr lvl="3"/>
-            <a:r>
-              <a:rPr lang="en-US"/>
-              <a:t>Fourth level</a:t>
-            </a:r>
-          </a:p>
-          <a:p>
-            <a:pPr lvl="4"/>
-            <a:r>
-              <a:rPr lang="en-US"/>
-              <a:t>Fifth level</a:t>
-            </a:r>
-          </a:p>
-        </p:txBody>
-      </p:sp>
-      <p:sp>
-        <p:nvSpPr>
-          <p:cNvPr id="6" name="Footer Placeholder 5"/>
-          <p:cNvSpPr>
-            <a:spLocks noGrp="1"/>
-          </p:cNvSpPr>
-          <p:nvPr>
-            <p:ph type="ftr" sz="quarter" idx="4"/>
-          </p:nvPr>
-        </p:nvSpPr>
-        <p:spPr>
-          <a:xfrm>
-            <a:off x="0" y="8685213"/>
-            <a:ext cx="2971800" cy="458787"/>
-          </a:xfrm>
-          <a:prstGeom prst="rect">
-            <a:avLst/>
-          </a:prstGeom>
-        </p:spPr>
-        <p:txBody>
-          <a:bodyPr vert="horz" lIns="91440" tIns="45720" rIns="91440" bIns="45720" rtlCol="0" anchor="b"/>
-          <a:lstStyle>
-            <a:lvl1pPr algn="l">
-              <a:defRPr sz="1200"/>
-            </a:lvl1pPr>
-          </a:lstStyle>
-          <a:p>
-            <a:endParaRPr lang="en-US"/>
-          </a:p>
-        </p:txBody>
-      </p:sp>
-      <p:sp>
-        <p:nvSpPr>
-          <p:cNvPr id="7" name="Slide Number Placeholder 6"/>
-          <p:cNvSpPr>
-            <a:spLocks noGrp="1"/>
-          </p:cNvSpPr>
-          <p:nvPr>
-            <p:ph type="sldNum" sz="quarter" idx="5"/>
-          </p:nvPr>
-        </p:nvSpPr>
-        <p:spPr>
-          <a:xfrm>
-            <a:off x="3884613" y="8685213"/>
-            <a:ext cx="2971800" cy="458787"/>
-          </a:xfrm>
-          <a:prstGeom prst="rect">
-            <a:avLst/>
-          </a:prstGeom>
-        </p:spPr>
-        <p:txBody>
-          <a:bodyPr vert="horz" lIns="91440" tIns="45720" rIns="91440" bIns="45720" rtlCol="0" anchor="b"/>
-          <a:lstStyle>
-            <a:lvl1pPr algn="r">
-              <a:defRPr sz="1200"/>
-            </a:lvl1pPr>
-          </a:lstStyle>
-          <a:p>
-            <a:fld id="{CE5E9CC1-C706-0F49-92D6-E571CC5EEA8F}" type="slidenum">
-              <a:rPr lang="en-US"/>
-              <a:t>‹#›</a:t>
-            </a:fld>
-            <a:endParaRPr lang="en-US"/>
-          </a:p>
-        </p:txBody>
-      </p:sp>
     </p:spTree>
     <p:extLst>
       <p:ext uri="{BB962C8B-B14F-4D97-AF65-F5344CB8AC3E}">
-        <p14:creationId xmlns:p14="http://schemas.microsoft.com/office/powerpoint/2010/main" val="1024086991"/>
+        <p14:creationId xmlns:p14="http://schemas.microsoft.com/office/powerpoint/2010/main" val="3082764684"/>
       </p:ext>
     </p:extLst>
   </p:cSld>
@@ -512,10 +293,6 @@
           <a:bodyPr/>
           <a:lstStyle/>
           <a:p>
-            <a:r>
-              <a:rPr lang="en-US" dirty="0"/>
-              <a:t/>
-            </a:r>
             <a:endParaRPr lang="en-US" dirty="0"/>
           </a:p>
         </p:txBody>
@@ -600,10 +377,6 @@
           <a:bodyPr/>
           <a:lstStyle/>
           <a:p>
-            <a:r>
-              <a:rPr lang="en-US" dirty="0"/>
-              <a:t/>
-            </a:r>
             <a:endParaRPr lang="en-US" dirty="0"/>
           </a:p>
         </p:txBody>
@@ -688,10 +461,6 @@
           <a:bodyPr/>
           <a:lstStyle/>
           <a:p>
-            <a:r>
-              <a:rPr lang="en-US" dirty="0"/>
-              <a:t/>
-            </a:r>
             <a:endParaRPr lang="en-US" dirty="0"/>
           </a:p>
         </p:txBody>
@@ -776,10 +545,6 @@
           <a:bodyPr/>
           <a:lstStyle/>
           <a:p>
-            <a:r>
-              <a:rPr lang="en-US" dirty="0"/>
-              <a:t/>
-            </a:r>
             <a:endParaRPr lang="en-US" dirty="0"/>
           </a:p>
         </p:txBody>
@@ -864,10 +629,6 @@
           <a:bodyPr/>
           <a:lstStyle/>
           <a:p>
-            <a:r>
-              <a:rPr lang="en-US" dirty="0"/>
-              <a:t/>
-            </a:r>
             <a:endParaRPr lang="en-US" dirty="0"/>
           </a:p>
         </p:txBody>
@@ -952,10 +713,6 @@
           <a:bodyPr/>
           <a:lstStyle/>
           <a:p>
-            <a:r>
-              <a:rPr lang="en-US" dirty="0"/>
-              <a:t/>
-            </a:r>
             <a:endParaRPr lang="en-US" dirty="0"/>
           </a:p>
         </p:txBody>
@@ -1040,10 +797,6 @@
           <a:bodyPr/>
           <a:lstStyle/>
           <a:p>
-            <a:r>
-              <a:rPr lang="en-US" dirty="0"/>
-              <a:t/>
-            </a:r>
             <a:endParaRPr lang="en-US" dirty="0"/>
           </a:p>
         </p:txBody>
@@ -1128,10 +881,6 @@
           <a:bodyPr/>
           <a:lstStyle/>
           <a:p>
-            <a:r>
-              <a:rPr lang="en-US" dirty="0"/>
-              <a:t/>
-            </a:r>
             <a:endParaRPr lang="en-US" dirty="0"/>
           </a:p>
         </p:txBody>
@@ -1216,10 +965,6 @@
           <a:bodyPr/>
           <a:lstStyle/>
           <a:p>
-            <a:r>
-              <a:rPr lang="en-US" dirty="0"/>
-              <a:t/>
-            </a:r>
             <a:endParaRPr lang="en-US" dirty="0"/>
           </a:p>
         </p:txBody>
@@ -1304,10 +1049,6 @@
           <a:bodyPr/>
           <a:lstStyle/>
           <a:p>
-            <a:r>
-              <a:rPr lang="en-US" dirty="0"/>
-              <a:t/>
-            </a:r>
             <a:endParaRPr lang="en-US" dirty="0"/>
           </a:p>
         </p:txBody>
@@ -1392,10 +1133,6 @@
           <a:bodyPr/>
           <a:lstStyle/>
           <a:p>
-            <a:r>
-              <a:rPr lang="en-US" dirty="0"/>
-              <a:t/>
-            </a:r>
             <a:endParaRPr lang="en-US" dirty="0"/>
           </a:p>
         </p:txBody>
@@ -1480,10 +1217,6 @@
           <a:bodyPr/>
           <a:lstStyle/>
           <a:p>
-            <a:r>
-              <a:rPr lang="en-US" dirty="0"/>
-              <a:t/>
-            </a:r>
             <a:endParaRPr lang="en-US" dirty="0"/>
           </a:p>
         </p:txBody>
@@ -1568,10 +1301,6 @@
           <a:bodyPr/>
           <a:lstStyle/>
           <a:p>
-            <a:r>
-              <a:rPr lang="en-US" dirty="0"/>
-              <a:t/>
-            </a:r>
             <a:endParaRPr lang="en-US" dirty="0"/>
           </a:p>
         </p:txBody>
@@ -1645,6 +1374,11 @@
 <file path=ppt/slideMasters/slideMaster1.xml><?xml version="1.0" encoding="utf-8"?>
 <p:sldMaster xmlns:a="http://schemas.openxmlformats.org/drawingml/2006/main" xmlns:r="http://schemas.openxmlformats.org/officeDocument/2006/relationships" xmlns:p="http://schemas.openxmlformats.org/presentationml/2006/main">
   <p:cSld>
+    <p:bg>
+      <p:bgRef idx="1001">
+        <a:schemeClr val="bg1"/>
+      </p:bgRef>
+    </p:bg>
     <p:spTree>
       <p:nvGrpSpPr>
         <p:cNvPr id="1" name=""/>
@@ -1927,6 +1661,7 @@
         <a:solidFill>
           <a:srgbClr val="0B1F3A"/>
         </a:solidFill>
+        <a:effectLst/>
       </p:bgPr>
     </p:bg>
     <p:spTree>
@@ -1945,14 +1680,14 @@
       </p:grpSpPr>
       <p:pic>
         <p:nvPicPr>
-          <p:cNvPr id="2" name="Image 0" descr="/home/user/BasicRobotLessons/docs/presentations/v3/template/assets/logo/team5010-logo-onnavy.png">    </p:cNvPr>
+          <p:cNvPr id="2" name="Image 0" descr="/home/user/BasicRobotLessons/docs/presentations/v3/template/assets/logo/team5010-logo-onnavy.png"/>
           <p:cNvPicPr>
             <a:picLocks noChangeAspect="1"/>
           </p:cNvPicPr>
           <p:nvPr/>
         </p:nvPicPr>
         <p:blipFill>
-          <a:blip r:embed="rId1"/>
+          <a:blip r:embed="rId3"/>
           <a:stretch>
             <a:fillRect/>
           </a:stretch>
@@ -1988,11 +1723,11 @@
           <a:bodyPr wrap="square" lIns="0" tIns="0" rIns="0" bIns="0" rtlCol="0" anchor="ctr"/>
           <a:lstStyle/>
           <a:p>
-            <a:pPr indent="0" marL="0">
-              <a:buNone/>
-            </a:pPr>
-            <a:r>
-              <a:rPr lang="en-US" sz="2000" b="1" spc="300" kern="0" dirty="0">
+            <a:pPr marL="0" indent="0">
+              <a:buNone/>
+            </a:pPr>
+            <a:r>
+              <a:rPr lang="en-US" sz="2000" b="1" kern="0" spc="300" dirty="0">
                 <a:solidFill>
                   <a:srgbClr val="1B9AAA"/>
                 </a:solidFill>
@@ -2027,11 +1762,11 @@
           <a:bodyPr wrap="square" lIns="0" tIns="0" rIns="0" bIns="0" rtlCol="0" anchor="ctr"/>
           <a:lstStyle/>
           <a:p>
-            <a:pPr indent="0" marL="0">
-              <a:buNone/>
-            </a:pPr>
-            <a:r>
-              <a:rPr lang="en-US" sz="2200" b="1" spc="200" kern="0" dirty="0">
+            <a:pPr marL="0" indent="0">
+              <a:buNone/>
+            </a:pPr>
+            <a:r>
+              <a:rPr lang="en-US" sz="2200" b="1" kern="0" spc="200" dirty="0">
                 <a:solidFill>
                   <a:srgbClr val="FF5010"/>
                 </a:solidFill>
@@ -2066,7 +1801,7 @@
           <a:bodyPr wrap="square" lIns="0" tIns="0" rIns="0" bIns="0" rtlCol="0" anchor="ctr"/>
           <a:lstStyle/>
           <a:p>
-            <a:pPr indent="0" marL="0">
+            <a:pPr marL="0" indent="0">
               <a:buNone/>
             </a:pPr>
             <a:r>
@@ -2092,7 +1827,7 @@
         </p:nvSpPr>
         <p:spPr>
           <a:xfrm>
-            <a:off x="777240" y="3611880"/>
+            <a:off x="777240" y="3383280"/>
             <a:ext cx="8686800" cy="640080"/>
           </a:xfrm>
           <a:prstGeom prst="rect">
@@ -2105,7 +1840,7 @@
           <a:bodyPr wrap="square" lIns="0" tIns="0" rIns="0" bIns="0" rtlCol="0" anchor="ctr"/>
           <a:lstStyle/>
           <a:p>
-            <a:pPr indent="0" marL="0">
+            <a:pPr marL="0" indent="0">
               <a:buNone/>
             </a:pPr>
             <a:r>
@@ -2144,11 +1879,11 @@
           <a:bodyPr wrap="square" lIns="0" tIns="0" rIns="0" bIns="0" rtlCol="0" anchor="ctr"/>
           <a:lstStyle/>
           <a:p>
-            <a:pPr indent="0" marL="0">
-              <a:buNone/>
-            </a:pPr>
-            <a:r>
-              <a:rPr lang="en-US" sz="2000" spc="100" kern="0" dirty="0">
+            <a:pPr marL="0" indent="0">
+              <a:buNone/>
+            </a:pPr>
+            <a:r>
+              <a:rPr lang="en-US" sz="2000" kern="0" spc="100" dirty="0">
                 <a:solidFill>
                   <a:srgbClr val="89A0BE"/>
                 </a:solidFill>
@@ -2178,6 +1913,7 @@
         <a:solidFill>
           <a:srgbClr val="FFFFFF"/>
         </a:solidFill>
+        <a:effectLst/>
       </p:bgPr>
     </p:bg>
     <p:spTree>
@@ -2213,17 +1949,24 @@
           </a:solidFill>
           <a:ln/>
         </p:spPr>
+        <p:txBody>
+          <a:bodyPr/>
+          <a:lstStyle/>
+          <a:p>
+            <a:endParaRPr lang="en-US"/>
+          </a:p>
+        </p:txBody>
       </p:sp>
       <p:pic>
         <p:nvPicPr>
-          <p:cNvPr id="3" name="Image 0" descr="/home/user/BasicRobotLessons/docs/presentations/v3/template/assets/icons/clouduploadalt_white.png">    </p:cNvPr>
+          <p:cNvPr id="3" name="Image 0" descr="/home/user/BasicRobotLessons/docs/presentations/v3/template/assets/icons/clouduploadalt_white.png"/>
           <p:cNvPicPr>
             <a:picLocks noChangeAspect="1"/>
           </p:cNvPicPr>
           <p:nvPr/>
         </p:nvPicPr>
         <p:blipFill>
-          <a:blip r:embed="rId1"/>
+          <a:blip r:embed="rId3"/>
           <a:stretch>
             <a:fillRect/>
           </a:stretch>
@@ -2259,11 +2002,11 @@
           <a:bodyPr wrap="square" lIns="0" tIns="0" rIns="0" bIns="0" rtlCol="0" anchor="ctr"/>
           <a:lstStyle/>
           <a:p>
-            <a:pPr indent="0" marL="0">
-              <a:buNone/>
-            </a:pPr>
-            <a:r>
-              <a:rPr lang="en-US" sz="2000" b="1" spc="150" kern="0" dirty="0">
+            <a:pPr marL="0" indent="0">
+              <a:buNone/>
+            </a:pPr>
+            <a:r>
+              <a:rPr lang="en-US" sz="2000" b="1" kern="0" spc="150" dirty="0">
                 <a:solidFill>
                   <a:srgbClr val="FF5010"/>
                 </a:solidFill>
@@ -2298,7 +2041,7 @@
           <a:bodyPr wrap="square" lIns="0" tIns="0" rIns="0" bIns="0" rtlCol="0" anchor="ctr"/>
           <a:lstStyle/>
           <a:p>
-            <a:pPr indent="0" marL="0">
+            <a:pPr marL="0" indent="0">
               <a:buNone/>
             </a:pPr>
             <a:r>
@@ -2337,13 +2080,20 @@
           </a:solidFill>
           <a:ln/>
           <a:effectLst>
-            <a:outerShdw sx="100000" sy="100000" kx="0" ky="0" algn="bl" rotWithShape="0" blurRad="101600" dist="38100" dir="5400000">
+            <a:outerShdw blurRad="101600" dist="38100" dir="5400000" algn="bl" rotWithShape="0">
               <a:srgbClr val="0B1F3A">
                 <a:alpha val="35000"/>
               </a:srgbClr>
             </a:outerShdw>
           </a:effectLst>
         </p:spPr>
+        <p:txBody>
+          <a:bodyPr/>
+          <a:lstStyle/>
+          <a:p>
+            <a:endParaRPr lang="en-US"/>
+          </a:p>
+        </p:txBody>
       </p:sp>
       <p:sp>
         <p:nvSpPr>
@@ -2364,6 +2114,13 @@
           </a:solidFill>
           <a:ln/>
         </p:spPr>
+        <p:txBody>
+          <a:bodyPr/>
+          <a:lstStyle/>
+          <a:p>
+            <a:endParaRPr lang="en-US"/>
+          </a:p>
+        </p:txBody>
       </p:sp>
       <p:sp>
         <p:nvSpPr>
@@ -2384,6 +2141,13 @@
           </a:solidFill>
           <a:ln/>
         </p:spPr>
+        <p:txBody>
+          <a:bodyPr/>
+          <a:lstStyle/>
+          <a:p>
+            <a:endParaRPr lang="en-US"/>
+          </a:p>
+        </p:txBody>
       </p:sp>
       <p:sp>
         <p:nvSpPr>
@@ -2404,6 +2168,13 @@
           </a:solidFill>
           <a:ln/>
         </p:spPr>
+        <p:txBody>
+          <a:bodyPr/>
+          <a:lstStyle/>
+          <a:p>
+            <a:endParaRPr lang="en-US"/>
+          </a:p>
+        </p:txBody>
       </p:sp>
       <p:sp>
         <p:nvSpPr>
@@ -2426,7 +2197,7 @@
           <a:bodyPr wrap="square" lIns="0" tIns="0" rIns="0" bIns="0" rtlCol="0" anchor="t"/>
           <a:lstStyle/>
           <a:p>
-            <a:pPr indent="0" marL="0">
+            <a:pPr marL="0" indent="0">
               <a:lnSpc>
                 <a:spcPct val="120000"/>
               </a:lnSpc>
@@ -2468,6 +2239,13 @@
           </a:solidFill>
           <a:ln/>
         </p:spPr>
+        <p:txBody>
+          <a:bodyPr/>
+          <a:lstStyle/>
+          <a:p>
+            <a:endParaRPr lang="en-US"/>
+          </a:p>
+        </p:txBody>
       </p:sp>
       <p:sp>
         <p:nvSpPr>
@@ -2490,7 +2268,7 @@
           <a:bodyPr wrap="square" lIns="0" tIns="0" rIns="0" bIns="0" rtlCol="0" anchor="t"/>
           <a:lstStyle/>
           <a:p>
-            <a:pPr indent="0" marL="0">
+            <a:pPr marL="0" indent="0">
               <a:lnSpc>
                 <a:spcPct val="120000"/>
               </a:lnSpc>
@@ -2532,7 +2310,7 @@
           <a:bodyPr wrap="square" lIns="0" tIns="0" rIns="0" bIns="0" rtlCol="0" anchor="t"/>
           <a:lstStyle/>
           <a:p>
-            <a:pPr indent="0" marL="0">
+            <a:pPr marL="0" indent="0">
               <a:lnSpc>
                 <a:spcPct val="125000"/>
               </a:lnSpc>
@@ -2574,11 +2352,11 @@
           <a:bodyPr wrap="square" lIns="0" tIns="0" rIns="0" bIns="0" rtlCol="0" anchor="ctr"/>
           <a:lstStyle/>
           <a:p>
-            <a:pPr indent="0" marL="0">
-              <a:buNone/>
-            </a:pPr>
-            <a:r>
-              <a:rPr lang="en-US" sz="2000" spc="100" kern="0" dirty="0">
+            <a:pPr marL="0" indent="0">
+              <a:buNone/>
+            </a:pPr>
+            <a:r>
+              <a:rPr lang="en-US" sz="2000" kern="0" spc="100" dirty="0">
                 <a:solidFill>
                   <a:srgbClr val="5B6B84"/>
                 </a:solidFill>
@@ -2613,7 +2391,7 @@
           <a:bodyPr wrap="square" lIns="0" tIns="0" rIns="0" bIns="0" rtlCol="0" anchor="ctr"/>
           <a:lstStyle/>
           <a:p>
-            <a:pPr algn="r" indent="0" marL="0">
+            <a:pPr marL="0" indent="0" algn="r">
               <a:buNone/>
             </a:pPr>
             <a:r>
@@ -2633,14 +2411,14 @@
       </p:sp>
       <p:pic>
         <p:nvPicPr>
-          <p:cNvPr id="16" name="Image 1" descr="/home/user/BasicRobotLessons/docs/presentations/v3/template/assets/logo/team5010-logo-onwhite.png">    </p:cNvPr>
+          <p:cNvPr id="16" name="Image 1" descr="/home/user/BasicRobotLessons/docs/presentations/v3/template/assets/logo/team5010-logo-onwhite.png"/>
           <p:cNvPicPr>
             <a:picLocks noChangeAspect="1"/>
           </p:cNvPicPr>
           <p:nvPr/>
         </p:nvPicPr>
         <p:blipFill>
-          <a:blip r:embed="rId2"/>
+          <a:blip r:embed="rId4"/>
           <a:stretch>
             <a:fillRect/>
           </a:stretch>
@@ -2671,6 +2449,7 @@
         <a:solidFill>
           <a:srgbClr val="0B1F3A"/>
         </a:solidFill>
+        <a:effectLst/>
       </p:bgPr>
     </p:bg>
     <p:spTree>
@@ -2706,17 +2485,24 @@
           </a:solidFill>
           <a:ln/>
         </p:spPr>
+        <p:txBody>
+          <a:bodyPr/>
+          <a:lstStyle/>
+          <a:p>
+            <a:endParaRPr lang="en-US"/>
+          </a:p>
+        </p:txBody>
       </p:sp>
       <p:pic>
         <p:nvPicPr>
-          <p:cNvPr id="3" name="Image 0" descr="/home/user/BasicRobotLessons/docs/presentations/v3/template/assets/icons/syncalt_white.png">    </p:cNvPr>
+          <p:cNvPr id="3" name="Image 0" descr="/home/user/BasicRobotLessons/docs/presentations/v3/template/assets/icons/syncalt_white.png"/>
           <p:cNvPicPr>
             <a:picLocks noChangeAspect="1"/>
           </p:cNvPicPr>
           <p:nvPr/>
         </p:nvPicPr>
         <p:blipFill>
-          <a:blip r:embed="rId1"/>
+          <a:blip r:embed="rId3"/>
           <a:stretch>
             <a:fillRect/>
           </a:stretch>
@@ -2752,11 +2538,11 @@
           <a:bodyPr wrap="square" lIns="0" tIns="0" rIns="0" bIns="0" rtlCol="0" anchor="ctr"/>
           <a:lstStyle/>
           <a:p>
-            <a:pPr indent="0" marL="0">
-              <a:buNone/>
-            </a:pPr>
-            <a:r>
-              <a:rPr lang="en-US" sz="2000" b="1" spc="100" kern="0" dirty="0">
+            <a:pPr marL="0" indent="0">
+              <a:buNone/>
+            </a:pPr>
+            <a:r>
+              <a:rPr lang="en-US" sz="2000" b="1" kern="0" spc="100" dirty="0">
                 <a:solidFill>
                   <a:srgbClr val="1B9AAA"/>
                 </a:solidFill>
@@ -2791,7 +2577,7 @@
           <a:bodyPr wrap="square" lIns="0" tIns="0" rIns="0" bIns="0" rtlCol="0" anchor="ctr"/>
           <a:lstStyle/>
           <a:p>
-            <a:pPr indent="0" marL="0">
+            <a:pPr marL="0" indent="0">
               <a:buNone/>
             </a:pPr>
             <a:r>
@@ -2830,13 +2616,20 @@
           </a:solidFill>
           <a:ln/>
           <a:effectLst>
-            <a:outerShdw sx="100000" sy="100000" kx="0" ky="0" algn="bl" rotWithShape="0" blurRad="101600" dist="38100" dir="5400000">
+            <a:outerShdw blurRad="101600" dist="38100" dir="5400000" algn="bl" rotWithShape="0">
               <a:srgbClr val="0B1F3A">
                 <a:alpha val="35000"/>
               </a:srgbClr>
             </a:outerShdw>
           </a:effectLst>
         </p:spPr>
+        <p:txBody>
+          <a:bodyPr/>
+          <a:lstStyle/>
+          <a:p>
+            <a:endParaRPr lang="en-US"/>
+          </a:p>
+        </p:txBody>
       </p:sp>
       <p:sp>
         <p:nvSpPr>
@@ -2857,6 +2650,13 @@
           </a:solidFill>
           <a:ln/>
         </p:spPr>
+        <p:txBody>
+          <a:bodyPr/>
+          <a:lstStyle/>
+          <a:p>
+            <a:endParaRPr lang="en-US"/>
+          </a:p>
+        </p:txBody>
       </p:sp>
       <p:sp>
         <p:nvSpPr>
@@ -2877,6 +2677,13 @@
           </a:solidFill>
           <a:ln/>
         </p:spPr>
+        <p:txBody>
+          <a:bodyPr/>
+          <a:lstStyle/>
+          <a:p>
+            <a:endParaRPr lang="en-US"/>
+          </a:p>
+        </p:txBody>
       </p:sp>
       <p:sp>
         <p:nvSpPr>
@@ -2897,6 +2704,13 @@
           </a:solidFill>
           <a:ln/>
         </p:spPr>
+        <p:txBody>
+          <a:bodyPr/>
+          <a:lstStyle/>
+          <a:p>
+            <a:endParaRPr lang="en-US"/>
+          </a:p>
+        </p:txBody>
       </p:sp>
       <p:sp>
         <p:nvSpPr>
@@ -2919,7 +2733,7 @@
           <a:bodyPr wrap="square" lIns="0" tIns="0" rIns="0" bIns="0" rtlCol="0" anchor="t"/>
           <a:lstStyle/>
           <a:p>
-            <a:pPr indent="0" marL="0">
+            <a:pPr marL="0" indent="0">
               <a:lnSpc>
                 <a:spcPct val="120000"/>
               </a:lnSpc>
@@ -2939,7 +2753,7 @@
             <a:endParaRPr lang="en-US" sz="1800" dirty="0"/>
           </a:p>
           <a:p>
-            <a:pPr indent="0" marL="0">
+            <a:pPr marL="0" indent="0">
               <a:lnSpc>
                 <a:spcPct val="120000"/>
               </a:lnSpc>
@@ -2959,7 +2773,7 @@
             <a:endParaRPr lang="en-US" sz="1800" dirty="0"/>
           </a:p>
           <a:p>
-            <a:pPr indent="0" marL="0">
+            <a:pPr marL="0" indent="0">
               <a:lnSpc>
                 <a:spcPct val="120000"/>
               </a:lnSpc>
@@ -2979,7 +2793,7 @@
             <a:endParaRPr lang="en-US" sz="1800" dirty="0"/>
           </a:p>
           <a:p>
-            <a:pPr indent="0" marL="0">
+            <a:pPr marL="0" indent="0">
               <a:lnSpc>
                 <a:spcPct val="120000"/>
               </a:lnSpc>
@@ -2999,7 +2813,7 @@
             <a:endParaRPr lang="en-US" sz="1800" dirty="0"/>
           </a:p>
           <a:p>
-            <a:pPr indent="0" marL="0">
+            <a:pPr marL="0" indent="0">
               <a:lnSpc>
                 <a:spcPct val="120000"/>
               </a:lnSpc>
@@ -3008,7 +2822,7 @@
             <a:endParaRPr lang="en-US" sz="1800" dirty="0"/>
           </a:p>
           <a:p>
-            <a:pPr indent="0" marL="0">
+            <a:pPr marL="0" indent="0">
               <a:lnSpc>
                 <a:spcPct val="120000"/>
               </a:lnSpc>
@@ -3050,6 +2864,13 @@
           </a:solidFill>
           <a:ln/>
         </p:spPr>
+        <p:txBody>
+          <a:bodyPr/>
+          <a:lstStyle/>
+          <a:p>
+            <a:endParaRPr lang="en-US"/>
+          </a:p>
+        </p:txBody>
       </p:sp>
       <p:sp>
         <p:nvSpPr>
@@ -3072,7 +2893,7 @@
           <a:bodyPr wrap="square" lIns="0" tIns="0" rIns="0" bIns="0" rtlCol="0" anchor="t"/>
           <a:lstStyle/>
           <a:p>
-            <a:pPr indent="0" marL="0">
+            <a:pPr marL="0" indent="0">
               <a:lnSpc>
                 <a:spcPct val="115000"/>
               </a:lnSpc>
@@ -3114,7 +2935,7 @@
           <a:bodyPr wrap="square" lIns="0" tIns="0" rIns="0" bIns="0" rtlCol="0" anchor="t"/>
           <a:lstStyle/>
           <a:p>
-            <a:pPr indent="0" marL="0">
+            <a:pPr marL="0" indent="0">
               <a:lnSpc>
                 <a:spcPct val="125000"/>
               </a:lnSpc>
@@ -3156,6 +2977,13 @@
           </a:solidFill>
           <a:ln/>
         </p:spPr>
+        <p:txBody>
+          <a:bodyPr/>
+          <a:lstStyle/>
+          <a:p>
+            <a:endParaRPr lang="en-US"/>
+          </a:p>
+        </p:txBody>
       </p:sp>
       <p:sp>
         <p:nvSpPr>
@@ -3178,7 +3006,7 @@
           <a:bodyPr wrap="square" lIns="0" tIns="0" rIns="0" bIns="0" rtlCol="0" anchor="ctr"/>
           <a:lstStyle/>
           <a:p>
-            <a:pPr indent="0" marL="0">
+            <a:pPr marL="0" indent="0">
               <a:lnSpc>
                 <a:spcPct val="125000"/>
               </a:lnSpc>
@@ -3220,11 +3048,11 @@
           <a:bodyPr wrap="square" lIns="0" tIns="0" rIns="0" bIns="0" rtlCol="0" anchor="ctr"/>
           <a:lstStyle/>
           <a:p>
-            <a:pPr indent="0" marL="0">
-              <a:buNone/>
-            </a:pPr>
-            <a:r>
-              <a:rPr lang="en-US" sz="2000" spc="100" kern="0" dirty="0">
+            <a:pPr marL="0" indent="0">
+              <a:buNone/>
+            </a:pPr>
+            <a:r>
+              <a:rPr lang="en-US" sz="2000" kern="0" spc="100" dirty="0">
                 <a:solidFill>
                   <a:srgbClr val="7A93B8"/>
                 </a:solidFill>
@@ -3259,7 +3087,7 @@
           <a:bodyPr wrap="square" lIns="0" tIns="0" rIns="0" bIns="0" rtlCol="0" anchor="ctr"/>
           <a:lstStyle/>
           <a:p>
-            <a:pPr algn="r" indent="0" marL="0">
+            <a:pPr marL="0" indent="0" algn="r">
               <a:buNone/>
             </a:pPr>
             <a:r>
@@ -3279,14 +3107,14 @@
       </p:sp>
       <p:pic>
         <p:nvPicPr>
-          <p:cNvPr id="18" name="Image 1" descr="/home/user/BasicRobotLessons/docs/presentations/v3/template/assets/logo/team5010-logo-onnavy.png">    </p:cNvPr>
+          <p:cNvPr id="18" name="Image 1" descr="/home/user/BasicRobotLessons/docs/presentations/v3/template/assets/logo/team5010-logo-onnavy.png"/>
           <p:cNvPicPr>
             <a:picLocks noChangeAspect="1"/>
           </p:cNvPicPr>
           <p:nvPr/>
         </p:nvPicPr>
         <p:blipFill>
-          <a:blip r:embed="rId2"/>
+          <a:blip r:embed="rId4"/>
           <a:stretch>
             <a:fillRect/>
           </a:stretch>
@@ -3317,6 +3145,7 @@
         <a:solidFill>
           <a:srgbClr val="0B1F3A"/>
         </a:solidFill>
+        <a:effectLst/>
       </p:bgPr>
     </p:bg>
     <p:spTree>
@@ -3352,17 +3181,24 @@
           </a:solidFill>
           <a:ln/>
         </p:spPr>
+        <p:txBody>
+          <a:bodyPr/>
+          <a:lstStyle/>
+          <a:p>
+            <a:endParaRPr lang="en-US"/>
+          </a:p>
+        </p:txBody>
       </p:sp>
       <p:pic>
         <p:nvPicPr>
-          <p:cNvPr id="3" name="Image 0" descr="/home/user/BasicRobotLessons/docs/presentations/v3/template/assets/icons/clipboardcheck_white.png">    </p:cNvPr>
+          <p:cNvPr id="3" name="Image 0" descr="/home/user/BasicRobotLessons/docs/presentations/v3/template/assets/icons/clipboardcheck_white.png"/>
           <p:cNvPicPr>
             <a:picLocks noChangeAspect="1"/>
           </p:cNvPicPr>
           <p:nvPr/>
         </p:nvPicPr>
         <p:blipFill>
-          <a:blip r:embed="rId1"/>
+          <a:blip r:embed="rId3"/>
           <a:stretch>
             <a:fillRect/>
           </a:stretch>
@@ -3398,11 +3234,11 @@
           <a:bodyPr wrap="square" lIns="0" tIns="0" rIns="0" bIns="0" rtlCol="0" anchor="ctr"/>
           <a:lstStyle/>
           <a:p>
-            <a:pPr indent="0" marL="0">
-              <a:buNone/>
-            </a:pPr>
-            <a:r>
-              <a:rPr lang="en-US" sz="2000" b="1" spc="100" kern="0" dirty="0">
+            <a:pPr marL="0" indent="0">
+              <a:buNone/>
+            </a:pPr>
+            <a:r>
+              <a:rPr lang="en-US" sz="2000" b="1" kern="0" spc="100" dirty="0">
                 <a:solidFill>
                   <a:srgbClr val="1B9AAA"/>
                 </a:solidFill>
@@ -3437,7 +3273,7 @@
           <a:bodyPr wrap="square" lIns="0" tIns="0" rIns="0" bIns="0" rtlCol="0" anchor="ctr"/>
           <a:lstStyle/>
           <a:p>
-            <a:pPr indent="0" marL="0">
+            <a:pPr marL="0" indent="0">
               <a:buNone/>
             </a:pPr>
             <a:r>
@@ -3476,6 +3312,13 @@
           </a:solidFill>
           <a:ln/>
         </p:spPr>
+        <p:txBody>
+          <a:bodyPr/>
+          <a:lstStyle/>
+          <a:p>
+            <a:endParaRPr lang="en-US"/>
+          </a:p>
+        </p:txBody>
       </p:sp>
       <p:sp>
         <p:nvSpPr>
@@ -3496,6 +3339,13 @@
           </a:solidFill>
           <a:ln/>
         </p:spPr>
+        <p:txBody>
+          <a:bodyPr/>
+          <a:lstStyle/>
+          <a:p>
+            <a:endParaRPr lang="en-US"/>
+          </a:p>
+        </p:txBody>
       </p:sp>
       <p:sp>
         <p:nvSpPr>
@@ -3518,7 +3368,7 @@
           <a:bodyPr wrap="square" lIns="0" tIns="0" rIns="0" bIns="0" rtlCol="0" anchor="ctr"/>
           <a:lstStyle/>
           <a:p>
-            <a:pPr algn="ctr" indent="0" marL="0">
+            <a:pPr marL="0" indent="0" algn="ctr">
               <a:buNone/>
             </a:pPr>
             <a:r>
@@ -3557,7 +3407,7 @@
           <a:bodyPr wrap="square" lIns="0" tIns="0" rIns="0" bIns="0" rtlCol="0" anchor="ctr"/>
           <a:lstStyle/>
           <a:p>
-            <a:pPr indent="0" marL="0">
+            <a:pPr marL="0" indent="0">
               <a:lnSpc>
                 <a:spcPct val="110000"/>
               </a:lnSpc>
@@ -3599,7 +3449,7 @@
           <a:bodyPr wrap="square" lIns="0" tIns="0" rIns="0" bIns="0" rtlCol="0" anchor="t"/>
           <a:lstStyle/>
           <a:p>
-            <a:pPr indent="0" marL="0">
+            <a:pPr marL="0" indent="0">
               <a:lnSpc>
                 <a:spcPct val="125000"/>
               </a:lnSpc>
@@ -3641,6 +3491,13 @@
           </a:solidFill>
           <a:ln/>
         </p:spPr>
+        <p:txBody>
+          <a:bodyPr/>
+          <a:lstStyle/>
+          <a:p>
+            <a:endParaRPr lang="en-US"/>
+          </a:p>
+        </p:txBody>
       </p:sp>
       <p:sp>
         <p:nvSpPr>
@@ -3661,6 +3518,13 @@
           </a:solidFill>
           <a:ln/>
         </p:spPr>
+        <p:txBody>
+          <a:bodyPr/>
+          <a:lstStyle/>
+          <a:p>
+            <a:endParaRPr lang="en-US"/>
+          </a:p>
+        </p:txBody>
       </p:sp>
       <p:sp>
         <p:nvSpPr>
@@ -3683,7 +3547,7 @@
           <a:bodyPr wrap="square" lIns="0" tIns="0" rIns="0" bIns="0" rtlCol="0" anchor="ctr"/>
           <a:lstStyle/>
           <a:p>
-            <a:pPr algn="ctr" indent="0" marL="0">
+            <a:pPr marL="0" indent="0" algn="ctr">
               <a:buNone/>
             </a:pPr>
             <a:r>
@@ -3722,7 +3586,7 @@
           <a:bodyPr wrap="square" lIns="0" tIns="0" rIns="0" bIns="0" rtlCol="0" anchor="ctr"/>
           <a:lstStyle/>
           <a:p>
-            <a:pPr indent="0" marL="0">
+            <a:pPr marL="0" indent="0">
               <a:lnSpc>
                 <a:spcPct val="110000"/>
               </a:lnSpc>
@@ -3764,7 +3628,7 @@
           <a:bodyPr wrap="square" lIns="0" tIns="0" rIns="0" bIns="0" rtlCol="0" anchor="t"/>
           <a:lstStyle/>
           <a:p>
-            <a:pPr indent="0" marL="0">
+            <a:pPr marL="0" indent="0">
               <a:lnSpc>
                 <a:spcPct val="125000"/>
               </a:lnSpc>
@@ -3806,6 +3670,13 @@
           </a:solidFill>
           <a:ln/>
         </p:spPr>
+        <p:txBody>
+          <a:bodyPr/>
+          <a:lstStyle/>
+          <a:p>
+            <a:endParaRPr lang="en-US"/>
+          </a:p>
+        </p:txBody>
       </p:sp>
       <p:sp>
         <p:nvSpPr>
@@ -3826,6 +3697,13 @@
           </a:solidFill>
           <a:ln/>
         </p:spPr>
+        <p:txBody>
+          <a:bodyPr/>
+          <a:lstStyle/>
+          <a:p>
+            <a:endParaRPr lang="en-US"/>
+          </a:p>
+        </p:txBody>
       </p:sp>
       <p:sp>
         <p:nvSpPr>
@@ -3848,7 +3726,7 @@
           <a:bodyPr wrap="square" lIns="0" tIns="0" rIns="0" bIns="0" rtlCol="0" anchor="ctr"/>
           <a:lstStyle/>
           <a:p>
-            <a:pPr algn="ctr" indent="0" marL="0">
+            <a:pPr marL="0" indent="0" algn="ctr">
               <a:buNone/>
             </a:pPr>
             <a:r>
@@ -3887,7 +3765,7 @@
           <a:bodyPr wrap="square" lIns="0" tIns="0" rIns="0" bIns="0" rtlCol="0" anchor="ctr"/>
           <a:lstStyle/>
           <a:p>
-            <a:pPr indent="0" marL="0">
+            <a:pPr marL="0" indent="0">
               <a:lnSpc>
                 <a:spcPct val="110000"/>
               </a:lnSpc>
@@ -3929,7 +3807,7 @@
           <a:bodyPr wrap="square" lIns="0" tIns="0" rIns="0" bIns="0" rtlCol="0" anchor="t"/>
           <a:lstStyle/>
           <a:p>
-            <a:pPr indent="0" marL="0">
+            <a:pPr marL="0" indent="0">
               <a:lnSpc>
                 <a:spcPct val="125000"/>
               </a:lnSpc>
@@ -3971,6 +3849,13 @@
           </a:solidFill>
           <a:ln/>
         </p:spPr>
+        <p:txBody>
+          <a:bodyPr/>
+          <a:lstStyle/>
+          <a:p>
+            <a:endParaRPr lang="en-US"/>
+          </a:p>
+        </p:txBody>
       </p:sp>
       <p:sp>
         <p:nvSpPr>
@@ -3991,6 +3876,13 @@
           </a:solidFill>
           <a:ln/>
         </p:spPr>
+        <p:txBody>
+          <a:bodyPr/>
+          <a:lstStyle/>
+          <a:p>
+            <a:endParaRPr lang="en-US"/>
+          </a:p>
+        </p:txBody>
       </p:sp>
       <p:sp>
         <p:nvSpPr>
@@ -4013,7 +3905,7 @@
           <a:bodyPr wrap="square" lIns="0" tIns="0" rIns="0" bIns="0" rtlCol="0" anchor="ctr"/>
           <a:lstStyle/>
           <a:p>
-            <a:pPr algn="ctr" indent="0" marL="0">
+            <a:pPr marL="0" indent="0" algn="ctr">
               <a:buNone/>
             </a:pPr>
             <a:r>
@@ -4052,7 +3944,7 @@
           <a:bodyPr wrap="square" lIns="0" tIns="0" rIns="0" bIns="0" rtlCol="0" anchor="ctr"/>
           <a:lstStyle/>
           <a:p>
-            <a:pPr indent="0" marL="0">
+            <a:pPr marL="0" indent="0">
               <a:lnSpc>
                 <a:spcPct val="110000"/>
               </a:lnSpc>
@@ -4094,7 +3986,7 @@
           <a:bodyPr wrap="square" lIns="0" tIns="0" rIns="0" bIns="0" rtlCol="0" anchor="t"/>
           <a:lstStyle/>
           <a:p>
-            <a:pPr indent="0" marL="0">
+            <a:pPr marL="0" indent="0">
               <a:lnSpc>
                 <a:spcPct val="125000"/>
               </a:lnSpc>
@@ -4136,11 +4028,11 @@
           <a:bodyPr wrap="square" lIns="0" tIns="0" rIns="0" bIns="0" rtlCol="0" anchor="ctr"/>
           <a:lstStyle/>
           <a:p>
-            <a:pPr indent="0" marL="0">
-              <a:buNone/>
-            </a:pPr>
-            <a:r>
-              <a:rPr lang="en-US" sz="2000" spc="100" kern="0" dirty="0">
+            <a:pPr marL="0" indent="0">
+              <a:buNone/>
+            </a:pPr>
+            <a:r>
+              <a:rPr lang="en-US" sz="2000" kern="0" spc="100" dirty="0">
                 <a:solidFill>
                   <a:srgbClr val="7A93B8"/>
                 </a:solidFill>
@@ -4175,7 +4067,7 @@
           <a:bodyPr wrap="square" lIns="0" tIns="0" rIns="0" bIns="0" rtlCol="0" anchor="ctr"/>
           <a:lstStyle/>
           <a:p>
-            <a:pPr algn="r" indent="0" marL="0">
+            <a:pPr marL="0" indent="0" algn="r">
               <a:buNone/>
             </a:pPr>
             <a:r>
@@ -4195,14 +4087,14 @@
       </p:sp>
       <p:pic>
         <p:nvPicPr>
-          <p:cNvPr id="28" name="Image 1" descr="/home/user/BasicRobotLessons/docs/presentations/v3/template/assets/logo/team5010-logo-onnavy.png">    </p:cNvPr>
+          <p:cNvPr id="28" name="Image 1" descr="/home/user/BasicRobotLessons/docs/presentations/v3/template/assets/logo/team5010-logo-onnavy.png"/>
           <p:cNvPicPr>
             <a:picLocks noChangeAspect="1"/>
           </p:cNvPicPr>
           <p:nvPr/>
         </p:nvPicPr>
         <p:blipFill>
-          <a:blip r:embed="rId2"/>
+          <a:blip r:embed="rId4"/>
           <a:stretch>
             <a:fillRect/>
           </a:stretch>
@@ -4233,6 +4125,7 @@
         <a:solidFill>
           <a:srgbClr val="FFFFFF"/>
         </a:solidFill>
+        <a:effectLst/>
       </p:bgPr>
     </p:bg>
     <p:spTree>
@@ -4268,17 +4161,24 @@
           </a:solidFill>
           <a:ln/>
         </p:spPr>
+        <p:txBody>
+          <a:bodyPr/>
+          <a:lstStyle/>
+          <a:p>
+            <a:endParaRPr lang="en-US"/>
+          </a:p>
+        </p:txBody>
       </p:sp>
       <p:pic>
         <p:nvPicPr>
-          <p:cNvPr id="3" name="Image 0" descr="/home/user/BasicRobotLessons/docs/presentations/v3/template/assets/icons/graduationcap_white.png">    </p:cNvPr>
+          <p:cNvPr id="3" name="Image 0" descr="/home/user/BasicRobotLessons/docs/presentations/v3/template/assets/icons/graduationcap_white.png"/>
           <p:cNvPicPr>
             <a:picLocks noChangeAspect="1"/>
           </p:cNvPicPr>
           <p:nvPr/>
         </p:nvPicPr>
         <p:blipFill>
-          <a:blip r:embed="rId1"/>
+          <a:blip r:embed="rId3"/>
           <a:stretch>
             <a:fillRect/>
           </a:stretch>
@@ -4314,11 +4214,11 @@
           <a:bodyPr wrap="square" lIns="0" tIns="0" rIns="0" bIns="0" rtlCol="0" anchor="ctr"/>
           <a:lstStyle/>
           <a:p>
-            <a:pPr indent="0" marL="0">
-              <a:buNone/>
-            </a:pPr>
-            <a:r>
-              <a:rPr lang="en-US" sz="2000" b="1" spc="150" kern="0" dirty="0">
+            <a:pPr marL="0" indent="0">
+              <a:buNone/>
+            </a:pPr>
+            <a:r>
+              <a:rPr lang="en-US" sz="2000" b="1" kern="0" spc="150" dirty="0">
                 <a:solidFill>
                   <a:srgbClr val="FF5010"/>
                 </a:solidFill>
@@ -4353,7 +4253,7 @@
           <a:bodyPr wrap="square" lIns="0" tIns="0" rIns="0" bIns="0" rtlCol="0" anchor="ctr"/>
           <a:lstStyle/>
           <a:p>
-            <a:pPr indent="0" marL="0">
+            <a:pPr marL="0" indent="0">
               <a:buNone/>
             </a:pPr>
             <a:r>
@@ -4486,7 +4386,7 @@
           <a:bodyPr wrap="square" lIns="0" tIns="0" rIns="0" bIns="0" rtlCol="0" anchor="t"/>
           <a:lstStyle/>
           <a:p>
-            <a:pPr indent="0" marL="0">
+            <a:pPr marL="0" indent="0">
               <a:lnSpc>
                 <a:spcPct val="125000"/>
               </a:lnSpc>
@@ -4528,6 +4428,13 @@
           </a:solidFill>
           <a:ln/>
         </p:spPr>
+        <p:txBody>
+          <a:bodyPr/>
+          <a:lstStyle/>
+          <a:p>
+            <a:endParaRPr lang="en-US"/>
+          </a:p>
+        </p:txBody>
       </p:sp>
       <p:sp>
         <p:nvSpPr>
@@ -4550,11 +4457,11 @@
           <a:bodyPr wrap="square" lIns="0" tIns="0" rIns="0" bIns="0" rtlCol="0" anchor="ctr"/>
           <a:lstStyle/>
           <a:p>
-            <a:pPr indent="0" marL="0">
-              <a:buNone/>
-            </a:pPr>
-            <a:r>
-              <a:rPr lang="en-US" sz="2000" b="1" spc="120" kern="0" dirty="0">
+            <a:pPr marL="0" indent="0">
+              <a:buNone/>
+            </a:pPr>
+            <a:r>
+              <a:rPr lang="en-US" sz="2000" b="1" kern="0" spc="120" dirty="0">
                 <a:solidFill>
                   <a:srgbClr val="1B9AAA"/>
                 </a:solidFill>
@@ -4589,7 +4496,7 @@
           <a:bodyPr wrap="square" lIns="0" tIns="0" rIns="0" bIns="0" rtlCol="0" anchor="ctr"/>
           <a:lstStyle/>
           <a:p>
-            <a:pPr indent="0" marL="0">
+            <a:pPr marL="0" indent="0">
               <a:buNone/>
             </a:pPr>
             <a:r>
@@ -4628,7 +4535,7 @@
           <a:bodyPr wrap="square" lIns="0" tIns="0" rIns="0" bIns="0" rtlCol="0" anchor="ctr"/>
           <a:lstStyle/>
           <a:p>
-            <a:pPr indent="0" marL="0">
+            <a:pPr marL="0" indent="0">
               <a:buNone/>
             </a:pPr>
             <a:r>
@@ -4667,7 +4574,7 @@
           <a:bodyPr wrap="square" lIns="0" tIns="0" rIns="0" bIns="0" rtlCol="0" anchor="t"/>
           <a:lstStyle/>
           <a:p>
-            <a:pPr indent="0" marL="0">
+            <a:pPr marL="0" indent="0">
               <a:lnSpc>
                 <a:spcPct val="130000"/>
               </a:lnSpc>
@@ -4707,17 +4614,24 @@
           </a:solidFill>
           <a:ln/>
         </p:spPr>
+        <p:txBody>
+          <a:bodyPr/>
+          <a:lstStyle/>
+          <a:p>
+            <a:endParaRPr lang="en-US"/>
+          </a:p>
+        </p:txBody>
       </p:sp>
       <p:pic>
         <p:nvPicPr>
-          <p:cNvPr id="14" name="Image 1" descr="/home/user/BasicRobotLessons/docs/presentations/v3/template/assets/icons/arrowright_white.png">    </p:cNvPr>
+          <p:cNvPr id="14" name="Image 1" descr="/home/user/BasicRobotLessons/docs/presentations/v3/template/assets/icons/arrowright_white.png"/>
           <p:cNvPicPr>
             <a:picLocks noChangeAspect="1"/>
           </p:cNvPicPr>
           <p:nvPr/>
         </p:nvPicPr>
         <p:blipFill>
-          <a:blip r:embed="rId2"/>
+          <a:blip r:embed="rId4"/>
           <a:stretch>
             <a:fillRect/>
           </a:stretch>
@@ -4753,11 +4667,11 @@
           <a:bodyPr wrap="square" lIns="0" tIns="0" rIns="0" bIns="0" rtlCol="0" anchor="ctr"/>
           <a:lstStyle/>
           <a:p>
-            <a:pPr indent="0" marL="0">
-              <a:buNone/>
-            </a:pPr>
-            <a:r>
-              <a:rPr lang="en-US" sz="2000" spc="100" kern="0" dirty="0">
+            <a:pPr marL="0" indent="0">
+              <a:buNone/>
+            </a:pPr>
+            <a:r>
+              <a:rPr lang="en-US" sz="2000" kern="0" spc="100" dirty="0">
                 <a:solidFill>
                   <a:srgbClr val="5B6B84"/>
                 </a:solidFill>
@@ -4792,7 +4706,7 @@
           <a:bodyPr wrap="square" lIns="0" tIns="0" rIns="0" bIns="0" rtlCol="0" anchor="ctr"/>
           <a:lstStyle/>
           <a:p>
-            <a:pPr algn="r" indent="0" marL="0">
+            <a:pPr marL="0" indent="0" algn="r">
               <a:buNone/>
             </a:pPr>
             <a:r>
@@ -4812,14 +4726,14 @@
       </p:sp>
       <p:pic>
         <p:nvPicPr>
-          <p:cNvPr id="17" name="Image 2" descr="/home/user/BasicRobotLessons/docs/presentations/v3/template/assets/logo/team5010-logo-onwhite.png">    </p:cNvPr>
+          <p:cNvPr id="17" name="Image 2" descr="/home/user/BasicRobotLessons/docs/presentations/v3/template/assets/logo/team5010-logo-onwhite.png"/>
           <p:cNvPicPr>
             <a:picLocks noChangeAspect="1"/>
           </p:cNvPicPr>
           <p:nvPr/>
         </p:nvPicPr>
         <p:blipFill>
-          <a:blip r:embed="rId3"/>
+          <a:blip r:embed="rId5"/>
           <a:stretch>
             <a:fillRect/>
           </a:stretch>
@@ -4850,6 +4764,7 @@
         <a:solidFill>
           <a:srgbClr val="FFFFFF"/>
         </a:solidFill>
+        <a:effectLst/>
       </p:bgPr>
     </p:bg>
     <p:spTree>
@@ -4885,17 +4800,24 @@
           </a:solidFill>
           <a:ln/>
         </p:spPr>
+        <p:txBody>
+          <a:bodyPr/>
+          <a:lstStyle/>
+          <a:p>
+            <a:endParaRPr lang="en-US"/>
+          </a:p>
+        </p:txBody>
       </p:sp>
       <p:pic>
         <p:nvPicPr>
-          <p:cNvPr id="3" name="Image 0" descr="/home/user/BasicRobotLessons/docs/presentations/v3/template/assets/icons/bullseye_white.png">    </p:cNvPr>
+          <p:cNvPr id="3" name="Image 0" descr="/home/user/BasicRobotLessons/docs/presentations/v3/template/assets/icons/bullseye_white.png"/>
           <p:cNvPicPr>
             <a:picLocks noChangeAspect="1"/>
           </p:cNvPicPr>
           <p:nvPr/>
         </p:nvPicPr>
         <p:blipFill>
-          <a:blip r:embed="rId1"/>
+          <a:blip r:embed="rId3"/>
           <a:stretch>
             <a:fillRect/>
           </a:stretch>
@@ -4931,11 +4853,11 @@
           <a:bodyPr wrap="square" lIns="0" tIns="0" rIns="0" bIns="0" rtlCol="0" anchor="ctr"/>
           <a:lstStyle/>
           <a:p>
-            <a:pPr indent="0" marL="0">
-              <a:buNone/>
-            </a:pPr>
-            <a:r>
-              <a:rPr lang="en-US" sz="2000" b="1" spc="150" kern="0" dirty="0">
+            <a:pPr marL="0" indent="0">
+              <a:buNone/>
+            </a:pPr>
+            <a:r>
+              <a:rPr lang="en-US" sz="2000" b="1" kern="0" spc="150" dirty="0">
                 <a:solidFill>
                   <a:srgbClr val="FF5010"/>
                 </a:solidFill>
@@ -4970,7 +4892,7 @@
           <a:bodyPr wrap="square" lIns="0" tIns="0" rIns="0" bIns="0" rtlCol="0" anchor="ctr"/>
           <a:lstStyle/>
           <a:p>
-            <a:pPr indent="0" marL="0">
+            <a:pPr marL="0" indent="0">
               <a:buNone/>
             </a:pPr>
             <a:r>
@@ -5009,6 +4931,13 @@
           </a:solidFill>
           <a:ln/>
         </p:spPr>
+        <p:txBody>
+          <a:bodyPr/>
+          <a:lstStyle/>
+          <a:p>
+            <a:endParaRPr lang="en-US"/>
+          </a:p>
+        </p:txBody>
       </p:sp>
       <p:sp>
         <p:nvSpPr>
@@ -5031,7 +4960,7 @@
           <a:bodyPr wrap="square" lIns="0" tIns="0" rIns="0" bIns="0" rtlCol="0" anchor="ctr"/>
           <a:lstStyle/>
           <a:p>
-            <a:pPr indent="0" marL="0">
+            <a:pPr marL="0" indent="0">
               <a:lnSpc>
                 <a:spcPct val="125000"/>
               </a:lnSpc>
@@ -5071,17 +5000,24 @@
           </a:solidFill>
           <a:ln/>
         </p:spPr>
+        <p:txBody>
+          <a:bodyPr/>
+          <a:lstStyle/>
+          <a:p>
+            <a:endParaRPr lang="en-US"/>
+          </a:p>
+        </p:txBody>
       </p:sp>
       <p:pic>
         <p:nvPicPr>
-          <p:cNvPr id="9" name="Image 1" descr="/home/user/BasicRobotLessons/docs/presentations/v3/template/assets/icons/terminal_white.png">    </p:cNvPr>
+          <p:cNvPr id="9" name="Image 1" descr="/home/user/BasicRobotLessons/docs/presentations/v3/template/assets/icons/terminal_white.png"/>
           <p:cNvPicPr>
             <a:picLocks noChangeAspect="1"/>
           </p:cNvPicPr>
           <p:nvPr/>
         </p:nvPicPr>
         <p:blipFill>
-          <a:blip r:embed="rId2"/>
+          <a:blip r:embed="rId4"/>
           <a:stretch>
             <a:fillRect/>
           </a:stretch>
@@ -5117,11 +5053,11 @@
           <a:bodyPr wrap="square" lIns="0" tIns="0" rIns="0" bIns="0" rtlCol="0" anchor="ctr"/>
           <a:lstStyle/>
           <a:p>
-            <a:pPr indent="0" marL="0">
-              <a:buNone/>
-            </a:pPr>
-            <a:r>
-              <a:rPr lang="en-US" sz="2000" b="1" spc="50" kern="0" dirty="0">
+            <a:pPr marL="0" indent="0">
+              <a:buNone/>
+            </a:pPr>
+            <a:r>
+              <a:rPr lang="en-US" sz="2000" b="1" kern="0" spc="50" dirty="0">
                 <a:solidFill>
                   <a:srgbClr val="13294B"/>
                 </a:solidFill>
@@ -5248,17 +5184,24 @@
           </a:solidFill>
           <a:ln/>
         </p:spPr>
+        <p:txBody>
+          <a:bodyPr/>
+          <a:lstStyle/>
+          <a:p>
+            <a:endParaRPr lang="en-US"/>
+          </a:p>
+        </p:txBody>
       </p:sp>
       <p:pic>
         <p:nvPicPr>
-          <p:cNvPr id="13" name="Image 2" descr="/home/user/BasicRobotLessons/docs/presentations/v3/template/assets/icons/github_white.png">    </p:cNvPr>
+          <p:cNvPr id="13" name="Image 2" descr="/home/user/BasicRobotLessons/docs/presentations/v3/template/assets/icons/github_white.png"/>
           <p:cNvPicPr>
             <a:picLocks noChangeAspect="1"/>
           </p:cNvPicPr>
           <p:nvPr/>
         </p:nvPicPr>
         <p:blipFill>
-          <a:blip r:embed="rId3"/>
+          <a:blip r:embed="rId5"/>
           <a:stretch>
             <a:fillRect/>
           </a:stretch>
@@ -5294,11 +5237,11 @@
           <a:bodyPr wrap="square" lIns="0" tIns="0" rIns="0" bIns="0" rtlCol="0" anchor="ctr"/>
           <a:lstStyle/>
           <a:p>
-            <a:pPr indent="0" marL="0">
-              <a:buNone/>
-            </a:pPr>
-            <a:r>
-              <a:rPr lang="en-US" sz="2000" b="1" spc="50" kern="0" dirty="0">
+            <a:pPr marL="0" indent="0">
+              <a:buNone/>
+            </a:pPr>
+            <a:r>
+              <a:rPr lang="en-US" sz="2000" b="1" kern="0" spc="50" dirty="0">
                 <a:solidFill>
                   <a:srgbClr val="13294B"/>
                 </a:solidFill>
@@ -5427,11 +5370,11 @@
           <a:bodyPr wrap="square" lIns="0" tIns="0" rIns="0" bIns="0" rtlCol="0" anchor="ctr"/>
           <a:lstStyle/>
           <a:p>
-            <a:pPr indent="0" marL="0">
-              <a:buNone/>
-            </a:pPr>
-            <a:r>
-              <a:rPr lang="en-US" sz="2000" spc="100" kern="0" dirty="0">
+            <a:pPr marL="0" indent="0">
+              <a:buNone/>
+            </a:pPr>
+            <a:r>
+              <a:rPr lang="en-US" sz="2000" kern="0" spc="100" dirty="0">
                 <a:solidFill>
                   <a:srgbClr val="5B6B84"/>
                 </a:solidFill>
@@ -5466,7 +5409,7 @@
           <a:bodyPr wrap="square" lIns="0" tIns="0" rIns="0" bIns="0" rtlCol="0" anchor="ctr"/>
           <a:lstStyle/>
           <a:p>
-            <a:pPr algn="r" indent="0" marL="0">
+            <a:pPr marL="0" indent="0" algn="r">
               <a:buNone/>
             </a:pPr>
             <a:r>
@@ -5486,14 +5429,14 @@
       </p:sp>
       <p:pic>
         <p:nvPicPr>
-          <p:cNvPr id="18" name="Image 3" descr="/home/user/BasicRobotLessons/docs/presentations/v3/template/assets/logo/team5010-logo-onwhite.png">    </p:cNvPr>
+          <p:cNvPr id="18" name="Image 3" descr="/home/user/BasicRobotLessons/docs/presentations/v3/template/assets/logo/team5010-logo-onwhite.png"/>
           <p:cNvPicPr>
             <a:picLocks noChangeAspect="1"/>
           </p:cNvPicPr>
           <p:nvPr/>
         </p:nvPicPr>
         <p:blipFill>
-          <a:blip r:embed="rId4"/>
+          <a:blip r:embed="rId6"/>
           <a:stretch>
             <a:fillRect/>
           </a:stretch>
@@ -5524,6 +5467,7 @@
         <a:solidFill>
           <a:srgbClr val="FFFFFF"/>
         </a:solidFill>
+        <a:effectLst/>
       </p:bgPr>
     </p:bg>
     <p:spTree>
@@ -5559,17 +5503,24 @@
           </a:solidFill>
           <a:ln/>
         </p:spPr>
+        <p:txBody>
+          <a:bodyPr/>
+          <a:lstStyle/>
+          <a:p>
+            <a:endParaRPr lang="en-US"/>
+          </a:p>
+        </p:txBody>
       </p:sp>
       <p:pic>
         <p:nvPicPr>
-          <p:cNvPr id="3" name="Image 0" descr="/home/user/BasicRobotLessons/docs/presentations/v3/template/assets/icons/code_white.png">    </p:cNvPr>
+          <p:cNvPr id="3" name="Image 0" descr="/home/user/BasicRobotLessons/docs/presentations/v3/template/assets/icons/code_white.png"/>
           <p:cNvPicPr>
             <a:picLocks noChangeAspect="1"/>
           </p:cNvPicPr>
           <p:nvPr/>
         </p:nvPicPr>
         <p:blipFill>
-          <a:blip r:embed="rId1"/>
+          <a:blip r:embed="rId3"/>
           <a:stretch>
             <a:fillRect/>
           </a:stretch>
@@ -5605,11 +5556,11 @@
           <a:bodyPr wrap="square" lIns="0" tIns="0" rIns="0" bIns="0" rtlCol="0" anchor="ctr"/>
           <a:lstStyle/>
           <a:p>
-            <a:pPr indent="0" marL="0">
-              <a:buNone/>
-            </a:pPr>
-            <a:r>
-              <a:rPr lang="en-US" sz="2000" b="1" spc="150" kern="0" dirty="0">
+            <a:pPr marL="0" indent="0">
+              <a:buNone/>
+            </a:pPr>
+            <a:r>
+              <a:rPr lang="en-US" sz="2000" b="1" kern="0" spc="150" dirty="0">
                 <a:solidFill>
                   <a:srgbClr val="FF5010"/>
                 </a:solidFill>
@@ -5644,7 +5595,7 @@
           <a:bodyPr wrap="square" lIns="0" tIns="0" rIns="0" bIns="0" rtlCol="0" anchor="ctr"/>
           <a:lstStyle/>
           <a:p>
-            <a:pPr indent="0" marL="0">
+            <a:pPr marL="0" indent="0">
               <a:buNone/>
             </a:pPr>
             <a:r>
@@ -5681,6 +5632,13 @@
           </a:solidFill>
           <a:ln/>
         </p:spPr>
+        <p:txBody>
+          <a:bodyPr/>
+          <a:lstStyle/>
+          <a:p>
+            <a:endParaRPr lang="en-US"/>
+          </a:p>
+        </p:txBody>
       </p:sp>
       <p:sp>
         <p:nvSpPr>
@@ -5703,7 +5661,7 @@
           <a:bodyPr wrap="square" lIns="0" tIns="0" rIns="0" bIns="0" rtlCol="0" anchor="ctr"/>
           <a:lstStyle/>
           <a:p>
-            <a:pPr algn="ctr" indent="0" marL="0">
+            <a:pPr marL="0" indent="0" algn="ctr">
               <a:buNone/>
             </a:pPr>
             <a:r>
@@ -5742,7 +5700,7 @@
           <a:bodyPr wrap="square" lIns="0" tIns="0" rIns="0" bIns="0" rtlCol="0" anchor="ctr"/>
           <a:lstStyle/>
           <a:p>
-            <a:pPr indent="0" marL="0">
+            <a:pPr marL="0" indent="0">
               <a:buNone/>
             </a:pPr>
             <a:r>
@@ -5781,7 +5739,7 @@
           <a:bodyPr wrap="square" lIns="0" tIns="0" rIns="0" bIns="0" rtlCol="0" anchor="ctr"/>
           <a:lstStyle/>
           <a:p>
-            <a:pPr indent="0" marL="0">
+            <a:pPr marL="0" indent="0">
               <a:lnSpc>
                 <a:spcPct val="110000"/>
               </a:lnSpc>
@@ -5821,6 +5779,13 @@
           </a:solidFill>
           <a:ln/>
         </p:spPr>
+        <p:txBody>
+          <a:bodyPr/>
+          <a:lstStyle/>
+          <a:p>
+            <a:endParaRPr lang="en-US"/>
+          </a:p>
+        </p:txBody>
       </p:sp>
       <p:sp>
         <p:nvSpPr>
@@ -5843,7 +5808,7 @@
           <a:bodyPr wrap="square" lIns="0" tIns="0" rIns="0" bIns="0" rtlCol="0" anchor="ctr"/>
           <a:lstStyle/>
           <a:p>
-            <a:pPr algn="ctr" indent="0" marL="0">
+            <a:pPr marL="0" indent="0" algn="ctr">
               <a:buNone/>
             </a:pPr>
             <a:r>
@@ -5882,7 +5847,7 @@
           <a:bodyPr wrap="square" lIns="0" tIns="0" rIns="0" bIns="0" rtlCol="0" anchor="ctr"/>
           <a:lstStyle/>
           <a:p>
-            <a:pPr indent="0" marL="0">
+            <a:pPr marL="0" indent="0">
               <a:buNone/>
             </a:pPr>
             <a:r>
@@ -5921,7 +5886,7 @@
           <a:bodyPr wrap="square" lIns="0" tIns="0" rIns="0" bIns="0" rtlCol="0" anchor="ctr"/>
           <a:lstStyle/>
           <a:p>
-            <a:pPr indent="0" marL="0">
+            <a:pPr marL="0" indent="0">
               <a:lnSpc>
                 <a:spcPct val="110000"/>
               </a:lnSpc>
@@ -5961,6 +5926,13 @@
           </a:solidFill>
           <a:ln/>
         </p:spPr>
+        <p:txBody>
+          <a:bodyPr/>
+          <a:lstStyle/>
+          <a:p>
+            <a:endParaRPr lang="en-US"/>
+          </a:p>
+        </p:txBody>
       </p:sp>
       <p:sp>
         <p:nvSpPr>
@@ -5983,7 +5955,7 @@
           <a:bodyPr wrap="square" lIns="0" tIns="0" rIns="0" bIns="0" rtlCol="0" anchor="ctr"/>
           <a:lstStyle/>
           <a:p>
-            <a:pPr algn="ctr" indent="0" marL="0">
+            <a:pPr marL="0" indent="0" algn="ctr">
               <a:buNone/>
             </a:pPr>
             <a:r>
@@ -6022,7 +5994,7 @@
           <a:bodyPr wrap="square" lIns="0" tIns="0" rIns="0" bIns="0" rtlCol="0" anchor="ctr"/>
           <a:lstStyle/>
           <a:p>
-            <a:pPr indent="0" marL="0">
+            <a:pPr marL="0" indent="0">
               <a:buNone/>
             </a:pPr>
             <a:r>
@@ -6061,7 +6033,7 @@
           <a:bodyPr wrap="square" lIns="0" tIns="0" rIns="0" bIns="0" rtlCol="0" anchor="ctr"/>
           <a:lstStyle/>
           <a:p>
-            <a:pPr indent="0" marL="0">
+            <a:pPr marL="0" indent="0">
               <a:lnSpc>
                 <a:spcPct val="110000"/>
               </a:lnSpc>
@@ -6101,6 +6073,13 @@
           </a:solidFill>
           <a:ln/>
         </p:spPr>
+        <p:txBody>
+          <a:bodyPr/>
+          <a:lstStyle/>
+          <a:p>
+            <a:endParaRPr lang="en-US"/>
+          </a:p>
+        </p:txBody>
       </p:sp>
       <p:sp>
         <p:nvSpPr>
@@ -6123,7 +6102,7 @@
           <a:bodyPr wrap="square" lIns="0" tIns="0" rIns="0" bIns="0" rtlCol="0" anchor="ctr"/>
           <a:lstStyle/>
           <a:p>
-            <a:pPr algn="ctr" indent="0" marL="0">
+            <a:pPr marL="0" indent="0" algn="ctr">
               <a:buNone/>
             </a:pPr>
             <a:r>
@@ -6162,7 +6141,7 @@
           <a:bodyPr wrap="square" lIns="0" tIns="0" rIns="0" bIns="0" rtlCol="0" anchor="ctr"/>
           <a:lstStyle/>
           <a:p>
-            <a:pPr indent="0" marL="0">
+            <a:pPr marL="0" indent="0">
               <a:buNone/>
             </a:pPr>
             <a:r>
@@ -6201,7 +6180,7 @@
           <a:bodyPr wrap="square" lIns="0" tIns="0" rIns="0" bIns="0" rtlCol="0" anchor="ctr"/>
           <a:lstStyle/>
           <a:p>
-            <a:pPr indent="0" marL="0">
+            <a:pPr marL="0" indent="0">
               <a:lnSpc>
                 <a:spcPct val="110000"/>
               </a:lnSpc>
@@ -6241,6 +6220,13 @@
           </a:solidFill>
           <a:ln/>
         </p:spPr>
+        <p:txBody>
+          <a:bodyPr/>
+          <a:lstStyle/>
+          <a:p>
+            <a:endParaRPr lang="en-US"/>
+          </a:p>
+        </p:txBody>
       </p:sp>
       <p:sp>
         <p:nvSpPr>
@@ -6263,7 +6249,7 @@
           <a:bodyPr wrap="square" lIns="0" tIns="0" rIns="0" bIns="0" rtlCol="0" anchor="ctr"/>
           <a:lstStyle/>
           <a:p>
-            <a:pPr algn="ctr" indent="0" marL="0">
+            <a:pPr marL="0" indent="0" algn="ctr">
               <a:buNone/>
             </a:pPr>
             <a:r>
@@ -6302,7 +6288,7 @@
           <a:bodyPr wrap="square" lIns="0" tIns="0" rIns="0" bIns="0" rtlCol="0" anchor="ctr"/>
           <a:lstStyle/>
           <a:p>
-            <a:pPr indent="0" marL="0">
+            <a:pPr marL="0" indent="0">
               <a:buNone/>
             </a:pPr>
             <a:r>
@@ -6341,7 +6327,7 @@
           <a:bodyPr wrap="square" lIns="0" tIns="0" rIns="0" bIns="0" rtlCol="0" anchor="ctr"/>
           <a:lstStyle/>
           <a:p>
-            <a:pPr indent="0" marL="0">
+            <a:pPr marL="0" indent="0">
               <a:lnSpc>
                 <a:spcPct val="110000"/>
               </a:lnSpc>
@@ -6383,11 +6369,11 @@
           <a:bodyPr wrap="square" lIns="0" tIns="0" rIns="0" bIns="0" rtlCol="0" anchor="ctr"/>
           <a:lstStyle/>
           <a:p>
-            <a:pPr indent="0" marL="0">
-              <a:buNone/>
-            </a:pPr>
-            <a:r>
-              <a:rPr lang="en-US" sz="2000" spc="100" kern="0" dirty="0">
+            <a:pPr marL="0" indent="0">
+              <a:buNone/>
+            </a:pPr>
+            <a:r>
+              <a:rPr lang="en-US" sz="2000" kern="0" spc="100" dirty="0">
                 <a:solidFill>
                   <a:srgbClr val="5B6B84"/>
                 </a:solidFill>
@@ -6422,7 +6408,7 @@
           <a:bodyPr wrap="square" lIns="0" tIns="0" rIns="0" bIns="0" rtlCol="0" anchor="ctr"/>
           <a:lstStyle/>
           <a:p>
-            <a:pPr algn="r" indent="0" marL="0">
+            <a:pPr marL="0" indent="0" algn="r">
               <a:buNone/>
             </a:pPr>
             <a:r>
@@ -6442,14 +6428,14 @@
       </p:sp>
       <p:pic>
         <p:nvPicPr>
-          <p:cNvPr id="28" name="Image 1" descr="/home/user/BasicRobotLessons/docs/presentations/v3/template/assets/logo/team5010-logo-onwhite.png">    </p:cNvPr>
+          <p:cNvPr id="28" name="Image 1" descr="/home/user/BasicRobotLessons/docs/presentations/v3/template/assets/logo/team5010-logo-onwhite.png"/>
           <p:cNvPicPr>
             <a:picLocks noChangeAspect="1"/>
           </p:cNvPicPr>
           <p:nvPr/>
         </p:nvPicPr>
         <p:blipFill>
-          <a:blip r:embed="rId2"/>
+          <a:blip r:embed="rId4"/>
           <a:stretch>
             <a:fillRect/>
           </a:stretch>
@@ -6480,6 +6466,7 @@
         <a:solidFill>
           <a:srgbClr val="FFFFFF"/>
         </a:solidFill>
+        <a:effectLst/>
       </p:bgPr>
     </p:bg>
     <p:spTree>
@@ -6515,17 +6502,24 @@
           </a:solidFill>
           <a:ln/>
         </p:spPr>
+        <p:txBody>
+          <a:bodyPr/>
+          <a:lstStyle/>
+          <a:p>
+            <a:endParaRPr lang="en-US"/>
+          </a:p>
+        </p:txBody>
       </p:sp>
       <p:pic>
         <p:nvPicPr>
-          <p:cNvPr id="3" name="Image 0" descr="/home/user/BasicRobotLessons/docs/presentations/v3/template/assets/icons/download_white.png">    </p:cNvPr>
+          <p:cNvPr id="3" name="Image 0" descr="/home/user/BasicRobotLessons/docs/presentations/v3/template/assets/icons/download_white.png"/>
           <p:cNvPicPr>
             <a:picLocks noChangeAspect="1"/>
           </p:cNvPicPr>
           <p:nvPr/>
         </p:nvPicPr>
         <p:blipFill>
-          <a:blip r:embed="rId1"/>
+          <a:blip r:embed="rId3"/>
           <a:stretch>
             <a:fillRect/>
           </a:stretch>
@@ -6561,11 +6555,11 @@
           <a:bodyPr wrap="square" lIns="0" tIns="0" rIns="0" bIns="0" rtlCol="0" anchor="ctr"/>
           <a:lstStyle/>
           <a:p>
-            <a:pPr indent="0" marL="0">
-              <a:buNone/>
-            </a:pPr>
-            <a:r>
-              <a:rPr lang="en-US" sz="2000" b="1" spc="150" kern="0" dirty="0">
+            <a:pPr marL="0" indent="0">
+              <a:buNone/>
+            </a:pPr>
+            <a:r>
+              <a:rPr lang="en-US" sz="2000" b="1" kern="0" spc="150" dirty="0">
                 <a:solidFill>
                   <a:srgbClr val="FF5010"/>
                 </a:solidFill>
@@ -6600,7 +6594,7 @@
           <a:bodyPr wrap="square" lIns="0" tIns="0" rIns="0" bIns="0" rtlCol="0" anchor="ctr"/>
           <a:lstStyle/>
           <a:p>
-            <a:pPr indent="0" marL="0">
+            <a:pPr marL="0" indent="0">
               <a:buNone/>
             </a:pPr>
             <a:r>
@@ -6639,13 +6633,20 @@
           </a:solidFill>
           <a:ln/>
           <a:effectLst>
-            <a:outerShdw sx="100000" sy="100000" kx="0" ky="0" algn="bl" rotWithShape="0" blurRad="101600" dist="38100" dir="5400000">
+            <a:outerShdw blurRad="101600" dist="38100" dir="5400000" algn="bl" rotWithShape="0">
               <a:srgbClr val="0B1F3A">
                 <a:alpha val="35000"/>
               </a:srgbClr>
             </a:outerShdw>
           </a:effectLst>
         </p:spPr>
+        <p:txBody>
+          <a:bodyPr/>
+          <a:lstStyle/>
+          <a:p>
+            <a:endParaRPr lang="en-US"/>
+          </a:p>
+        </p:txBody>
       </p:sp>
       <p:sp>
         <p:nvSpPr>
@@ -6666,6 +6667,13 @@
           </a:solidFill>
           <a:ln/>
         </p:spPr>
+        <p:txBody>
+          <a:bodyPr/>
+          <a:lstStyle/>
+          <a:p>
+            <a:endParaRPr lang="en-US"/>
+          </a:p>
+        </p:txBody>
       </p:sp>
       <p:sp>
         <p:nvSpPr>
@@ -6686,6 +6694,13 @@
           </a:solidFill>
           <a:ln/>
         </p:spPr>
+        <p:txBody>
+          <a:bodyPr/>
+          <a:lstStyle/>
+          <a:p>
+            <a:endParaRPr lang="en-US"/>
+          </a:p>
+        </p:txBody>
       </p:sp>
       <p:sp>
         <p:nvSpPr>
@@ -6706,6 +6721,13 @@
           </a:solidFill>
           <a:ln/>
         </p:spPr>
+        <p:txBody>
+          <a:bodyPr/>
+          <a:lstStyle/>
+          <a:p>
+            <a:endParaRPr lang="en-US"/>
+          </a:p>
+        </p:txBody>
       </p:sp>
       <p:sp>
         <p:nvSpPr>
@@ -6728,7 +6750,7 @@
           <a:bodyPr wrap="square" lIns="0" tIns="0" rIns="0" bIns="0" rtlCol="0" anchor="t"/>
           <a:lstStyle/>
           <a:p>
-            <a:pPr indent="0" marL="0">
+            <a:pPr marL="0" indent="0">
               <a:lnSpc>
                 <a:spcPct val="120000"/>
               </a:lnSpc>
@@ -6770,13 +6792,20 @@
           </a:solidFill>
           <a:ln/>
           <a:effectLst>
-            <a:outerShdw sx="100000" sy="100000" kx="0" ky="0" algn="bl" rotWithShape="0" blurRad="101600" dist="38100" dir="5400000">
+            <a:outerShdw blurRad="101600" dist="38100" dir="5400000" algn="bl" rotWithShape="0">
               <a:srgbClr val="0B1F3A">
                 <a:alpha val="35000"/>
               </a:srgbClr>
             </a:outerShdw>
           </a:effectLst>
         </p:spPr>
+        <p:txBody>
+          <a:bodyPr/>
+          <a:lstStyle/>
+          <a:p>
+            <a:endParaRPr lang="en-US"/>
+          </a:p>
+        </p:txBody>
       </p:sp>
       <p:sp>
         <p:nvSpPr>
@@ -6797,6 +6826,13 @@
           </a:solidFill>
           <a:ln/>
         </p:spPr>
+        <p:txBody>
+          <a:bodyPr/>
+          <a:lstStyle/>
+          <a:p>
+            <a:endParaRPr lang="en-US"/>
+          </a:p>
+        </p:txBody>
       </p:sp>
       <p:sp>
         <p:nvSpPr>
@@ -6817,6 +6853,13 @@
           </a:solidFill>
           <a:ln/>
         </p:spPr>
+        <p:txBody>
+          <a:bodyPr/>
+          <a:lstStyle/>
+          <a:p>
+            <a:endParaRPr lang="en-US"/>
+          </a:p>
+        </p:txBody>
       </p:sp>
       <p:sp>
         <p:nvSpPr>
@@ -6837,6 +6880,13 @@
           </a:solidFill>
           <a:ln/>
         </p:spPr>
+        <p:txBody>
+          <a:bodyPr/>
+          <a:lstStyle/>
+          <a:p>
+            <a:endParaRPr lang="en-US"/>
+          </a:p>
+        </p:txBody>
       </p:sp>
       <p:sp>
         <p:nvSpPr>
@@ -6859,7 +6909,7 @@
           <a:bodyPr wrap="square" lIns="0" tIns="0" rIns="0" bIns="0" rtlCol="0" anchor="t"/>
           <a:lstStyle/>
           <a:p>
-            <a:pPr indent="0" marL="0">
+            <a:pPr marL="0" indent="0">
               <a:lnSpc>
                 <a:spcPct val="120000"/>
               </a:lnSpc>
@@ -6879,7 +6929,7 @@
             <a:endParaRPr lang="en-US" sz="2000" dirty="0"/>
           </a:p>
           <a:p>
-            <a:pPr indent="0" marL="0">
+            <a:pPr marL="0" indent="0">
               <a:lnSpc>
                 <a:spcPct val="120000"/>
               </a:lnSpc>
@@ -6921,6 +6971,13 @@
           </a:solidFill>
           <a:ln/>
         </p:spPr>
+        <p:txBody>
+          <a:bodyPr/>
+          <a:lstStyle/>
+          <a:p>
+            <a:endParaRPr lang="en-US"/>
+          </a:p>
+        </p:txBody>
       </p:sp>
       <p:sp>
         <p:nvSpPr>
@@ -6943,7 +7000,7 @@
           <a:bodyPr wrap="square" lIns="0" tIns="0" rIns="0" bIns="0" rtlCol="0" anchor="t"/>
           <a:lstStyle/>
           <a:p>
-            <a:pPr indent="0" marL="0">
+            <a:pPr marL="0" indent="0">
               <a:lnSpc>
                 <a:spcPct val="120000"/>
               </a:lnSpc>
@@ -6985,11 +7042,11 @@
           <a:bodyPr wrap="square" lIns="0" tIns="0" rIns="0" bIns="0" rtlCol="0" anchor="ctr"/>
           <a:lstStyle/>
           <a:p>
-            <a:pPr indent="0" marL="0">
-              <a:buNone/>
-            </a:pPr>
-            <a:r>
-              <a:rPr lang="en-US" sz="2000" spc="100" kern="0" dirty="0">
+            <a:pPr marL="0" indent="0">
+              <a:buNone/>
+            </a:pPr>
+            <a:r>
+              <a:rPr lang="en-US" sz="2000" kern="0" spc="100" dirty="0">
                 <a:solidFill>
                   <a:srgbClr val="5B6B84"/>
                 </a:solidFill>
@@ -7024,7 +7081,7 @@
           <a:bodyPr wrap="square" lIns="0" tIns="0" rIns="0" bIns="0" rtlCol="0" anchor="ctr"/>
           <a:lstStyle/>
           <a:p>
-            <a:pPr algn="r" indent="0" marL="0">
+            <a:pPr marL="0" indent="0" algn="r">
               <a:buNone/>
             </a:pPr>
             <a:r>
@@ -7044,14 +7101,14 @@
       </p:sp>
       <p:pic>
         <p:nvPicPr>
-          <p:cNvPr id="20" name="Image 1" descr="/home/user/BasicRobotLessons/docs/presentations/v3/template/assets/logo/team5010-logo-onwhite.png">    </p:cNvPr>
+          <p:cNvPr id="20" name="Image 1" descr="/home/user/BasicRobotLessons/docs/presentations/v3/template/assets/logo/team5010-logo-onwhite.png"/>
           <p:cNvPicPr>
             <a:picLocks noChangeAspect="1"/>
           </p:cNvPicPr>
           <p:nvPr/>
         </p:nvPicPr>
         <p:blipFill>
-          <a:blip r:embed="rId2"/>
+          <a:blip r:embed="rId4"/>
           <a:stretch>
             <a:fillRect/>
           </a:stretch>
@@ -7082,6 +7139,7 @@
         <a:solidFill>
           <a:srgbClr val="FFFFFF"/>
         </a:solidFill>
+        <a:effectLst/>
       </p:bgPr>
     </p:bg>
     <p:spTree>
@@ -7117,17 +7175,24 @@
           </a:solidFill>
           <a:ln/>
         </p:spPr>
+        <p:txBody>
+          <a:bodyPr/>
+          <a:lstStyle/>
+          <a:p>
+            <a:endParaRPr lang="en-US"/>
+          </a:p>
+        </p:txBody>
       </p:sp>
       <p:pic>
         <p:nvPicPr>
-          <p:cNvPr id="3" name="Image 0" descr="/home/user/BasicRobotLessons/docs/presentations/v3/template/assets/icons/coffee_white.png">    </p:cNvPr>
+          <p:cNvPr id="3" name="Image 0" descr="/home/user/BasicRobotLessons/docs/presentations/v3/template/assets/icons/coffee_white.png"/>
           <p:cNvPicPr>
             <a:picLocks noChangeAspect="1"/>
           </p:cNvPicPr>
           <p:nvPr/>
         </p:nvPicPr>
         <p:blipFill>
-          <a:blip r:embed="rId1"/>
+          <a:blip r:embed="rId3"/>
           <a:stretch>
             <a:fillRect/>
           </a:stretch>
@@ -7163,11 +7228,11 @@
           <a:bodyPr wrap="square" lIns="0" tIns="0" rIns="0" bIns="0" rtlCol="0" anchor="ctr"/>
           <a:lstStyle/>
           <a:p>
-            <a:pPr indent="0" marL="0">
-              <a:buNone/>
-            </a:pPr>
-            <a:r>
-              <a:rPr lang="en-US" sz="2000" b="1" spc="150" kern="0" dirty="0">
+            <a:pPr marL="0" indent="0">
+              <a:buNone/>
+            </a:pPr>
+            <a:r>
+              <a:rPr lang="en-US" sz="2000" b="1" kern="0" spc="150" dirty="0">
                 <a:solidFill>
                   <a:srgbClr val="FF5010"/>
                 </a:solidFill>
@@ -7202,7 +7267,7 @@
           <a:bodyPr wrap="square" lIns="0" tIns="0" rIns="0" bIns="0" rtlCol="0" anchor="ctr"/>
           <a:lstStyle/>
           <a:p>
-            <a:pPr indent="0" marL="0">
+            <a:pPr marL="0" indent="0">
               <a:buNone/>
             </a:pPr>
             <a:r>
@@ -7241,13 +7306,20 @@
           </a:solidFill>
           <a:ln/>
           <a:effectLst>
-            <a:outerShdw sx="100000" sy="100000" kx="0" ky="0" algn="bl" rotWithShape="0" blurRad="101600" dist="38100" dir="5400000">
+            <a:outerShdw blurRad="101600" dist="38100" dir="5400000" algn="bl" rotWithShape="0">
               <a:srgbClr val="0B1F3A">
                 <a:alpha val="35000"/>
               </a:srgbClr>
             </a:outerShdw>
           </a:effectLst>
         </p:spPr>
+        <p:txBody>
+          <a:bodyPr/>
+          <a:lstStyle/>
+          <a:p>
+            <a:endParaRPr lang="en-US"/>
+          </a:p>
+        </p:txBody>
       </p:sp>
       <p:sp>
         <p:nvSpPr>
@@ -7268,6 +7340,13 @@
           </a:solidFill>
           <a:ln/>
         </p:spPr>
+        <p:txBody>
+          <a:bodyPr/>
+          <a:lstStyle/>
+          <a:p>
+            <a:endParaRPr lang="en-US"/>
+          </a:p>
+        </p:txBody>
       </p:sp>
       <p:sp>
         <p:nvSpPr>
@@ -7288,6 +7367,13 @@
           </a:solidFill>
           <a:ln/>
         </p:spPr>
+        <p:txBody>
+          <a:bodyPr/>
+          <a:lstStyle/>
+          <a:p>
+            <a:endParaRPr lang="en-US"/>
+          </a:p>
+        </p:txBody>
       </p:sp>
       <p:sp>
         <p:nvSpPr>
@@ -7308,6 +7394,13 @@
           </a:solidFill>
           <a:ln/>
         </p:spPr>
+        <p:txBody>
+          <a:bodyPr/>
+          <a:lstStyle/>
+          <a:p>
+            <a:endParaRPr lang="en-US"/>
+          </a:p>
+        </p:txBody>
       </p:sp>
       <p:sp>
         <p:nvSpPr>
@@ -7330,7 +7423,7 @@
           <a:bodyPr wrap="square" lIns="0" tIns="0" rIns="0" bIns="0" rtlCol="0" anchor="t"/>
           <a:lstStyle/>
           <a:p>
-            <a:pPr indent="0" marL="0">
+            <a:pPr marL="0" indent="0">
               <a:lnSpc>
                 <a:spcPct val="120000"/>
               </a:lnSpc>
@@ -7372,7 +7465,7 @@
           <a:bodyPr wrap="square" lIns="0" tIns="0" rIns="0" bIns="0" rtlCol="0" anchor="t"/>
           <a:lstStyle/>
           <a:p>
-            <a:pPr indent="0" marL="0">
+            <a:pPr marL="0" indent="0">
               <a:lnSpc>
                 <a:spcPct val="125000"/>
               </a:lnSpc>
@@ -7414,6 +7507,13 @@
           </a:solidFill>
           <a:ln/>
         </p:spPr>
+        <p:txBody>
+          <a:bodyPr/>
+          <a:lstStyle/>
+          <a:p>
+            <a:endParaRPr lang="en-US"/>
+          </a:p>
+        </p:txBody>
       </p:sp>
       <p:sp>
         <p:nvSpPr>
@@ -7436,11 +7536,11 @@
           <a:bodyPr wrap="square" lIns="0" tIns="0" rIns="0" bIns="0" rtlCol="0" anchor="ctr"/>
           <a:lstStyle/>
           <a:p>
-            <a:pPr indent="0" marL="0">
-              <a:buNone/>
-            </a:pPr>
-            <a:r>
-              <a:rPr lang="en-US" sz="2000" b="1" spc="50" kern="0" dirty="0">
+            <a:pPr marL="0" indent="0">
+              <a:buNone/>
+            </a:pPr>
+            <a:r>
+              <a:rPr lang="en-US" sz="2000" b="1" kern="0" spc="50" dirty="0">
                 <a:solidFill>
                   <a:srgbClr val="FF5010"/>
                 </a:solidFill>
@@ -7475,7 +7575,7 @@
           <a:bodyPr wrap="square" lIns="0" tIns="0" rIns="0" bIns="0" rtlCol="0" anchor="t"/>
           <a:lstStyle/>
           <a:p>
-            <a:pPr indent="0" marL="0">
+            <a:pPr marL="0" indent="0">
               <a:lnSpc>
                 <a:spcPct val="120000"/>
               </a:lnSpc>
@@ -7517,7 +7617,7 @@
           <a:bodyPr wrap="square" lIns="0" tIns="0" rIns="0" bIns="0" rtlCol="0" anchor="t"/>
           <a:lstStyle/>
           <a:p>
-            <a:pPr indent="0" marL="0">
+            <a:pPr marL="0" indent="0">
               <a:lnSpc>
                 <a:spcPct val="125000"/>
               </a:lnSpc>
@@ -7559,11 +7659,11 @@
           <a:bodyPr wrap="square" lIns="0" tIns="0" rIns="0" bIns="0" rtlCol="0" anchor="ctr"/>
           <a:lstStyle/>
           <a:p>
-            <a:pPr indent="0" marL="0">
-              <a:buNone/>
-            </a:pPr>
-            <a:r>
-              <a:rPr lang="en-US" sz="2000" spc="100" kern="0" dirty="0">
+            <a:pPr marL="0" indent="0">
+              <a:buNone/>
+            </a:pPr>
+            <a:r>
+              <a:rPr lang="en-US" sz="2000" kern="0" spc="100" dirty="0">
                 <a:solidFill>
                   <a:srgbClr val="5B6B84"/>
                 </a:solidFill>
@@ -7598,7 +7698,7 @@
           <a:bodyPr wrap="square" lIns="0" tIns="0" rIns="0" bIns="0" rtlCol="0" anchor="ctr"/>
           <a:lstStyle/>
           <a:p>
-            <a:pPr algn="r" indent="0" marL="0">
+            <a:pPr marL="0" indent="0" algn="r">
               <a:buNone/>
             </a:pPr>
             <a:r>
@@ -7618,14 +7718,14 @@
       </p:sp>
       <p:pic>
         <p:nvPicPr>
-          <p:cNvPr id="18" name="Image 1" descr="/home/user/BasicRobotLessons/docs/presentations/v3/template/assets/logo/team5010-logo-onwhite.png">    </p:cNvPr>
+          <p:cNvPr id="18" name="Image 1" descr="/home/user/BasicRobotLessons/docs/presentations/v3/template/assets/logo/team5010-logo-onwhite.png"/>
           <p:cNvPicPr>
             <a:picLocks noChangeAspect="1"/>
           </p:cNvPicPr>
           <p:nvPr/>
         </p:nvPicPr>
         <p:blipFill>
-          <a:blip r:embed="rId2"/>
+          <a:blip r:embed="rId4"/>
           <a:stretch>
             <a:fillRect/>
           </a:stretch>
@@ -7656,6 +7756,7 @@
         <a:solidFill>
           <a:srgbClr val="FFFFFF"/>
         </a:solidFill>
+        <a:effectLst/>
       </p:bgPr>
     </p:bg>
     <p:spTree>
@@ -7691,17 +7792,24 @@
           </a:solidFill>
           <a:ln/>
         </p:spPr>
+        <p:txBody>
+          <a:bodyPr/>
+          <a:lstStyle/>
+          <a:p>
+            <a:endParaRPr lang="en-US"/>
+          </a:p>
+        </p:txBody>
       </p:sp>
       <p:pic>
         <p:nvPicPr>
-          <p:cNvPr id="3" name="Image 0" descr="/home/user/BasicRobotLessons/docs/presentations/v3/template/assets/icons/folderopen_white.png">    </p:cNvPr>
+          <p:cNvPr id="3" name="Image 0" descr="/home/user/BasicRobotLessons/docs/presentations/v3/template/assets/icons/folderopen_white.png"/>
           <p:cNvPicPr>
             <a:picLocks noChangeAspect="1"/>
           </p:cNvPicPr>
           <p:nvPr/>
         </p:nvPicPr>
         <p:blipFill>
-          <a:blip r:embed="rId1"/>
+          <a:blip r:embed="rId3"/>
           <a:stretch>
             <a:fillRect/>
           </a:stretch>
@@ -7737,11 +7845,11 @@
           <a:bodyPr wrap="square" lIns="0" tIns="0" rIns="0" bIns="0" rtlCol="0" anchor="ctr"/>
           <a:lstStyle/>
           <a:p>
-            <a:pPr indent="0" marL="0">
-              <a:buNone/>
-            </a:pPr>
-            <a:r>
-              <a:rPr lang="en-US" sz="2000" b="1" spc="150" kern="0" dirty="0">
+            <a:pPr marL="0" indent="0">
+              <a:buNone/>
+            </a:pPr>
+            <a:r>
+              <a:rPr lang="en-US" sz="2000" b="1" kern="0" spc="150" dirty="0">
                 <a:solidFill>
                   <a:srgbClr val="FF5010"/>
                 </a:solidFill>
@@ -7776,7 +7884,7 @@
           <a:bodyPr wrap="square" lIns="0" tIns="0" rIns="0" bIns="0" rtlCol="0" anchor="ctr"/>
           <a:lstStyle/>
           <a:p>
-            <a:pPr indent="0" marL="0">
+            <a:pPr marL="0" indent="0">
               <a:buNone/>
             </a:pPr>
             <a:r>
@@ -7815,13 +7923,20 @@
           </a:solidFill>
           <a:ln/>
           <a:effectLst>
-            <a:outerShdw sx="100000" sy="100000" kx="0" ky="0" algn="bl" rotWithShape="0" blurRad="101600" dist="38100" dir="5400000">
+            <a:outerShdw blurRad="101600" dist="38100" dir="5400000" algn="bl" rotWithShape="0">
               <a:srgbClr val="0B1F3A">
                 <a:alpha val="35000"/>
               </a:srgbClr>
             </a:outerShdw>
           </a:effectLst>
         </p:spPr>
+        <p:txBody>
+          <a:bodyPr/>
+          <a:lstStyle/>
+          <a:p>
+            <a:endParaRPr lang="en-US"/>
+          </a:p>
+        </p:txBody>
       </p:sp>
       <p:sp>
         <p:nvSpPr>
@@ -7842,6 +7957,13 @@
           </a:solidFill>
           <a:ln/>
         </p:spPr>
+        <p:txBody>
+          <a:bodyPr/>
+          <a:lstStyle/>
+          <a:p>
+            <a:endParaRPr lang="en-US"/>
+          </a:p>
+        </p:txBody>
       </p:sp>
       <p:sp>
         <p:nvSpPr>
@@ -7862,6 +7984,13 @@
           </a:solidFill>
           <a:ln/>
         </p:spPr>
+        <p:txBody>
+          <a:bodyPr/>
+          <a:lstStyle/>
+          <a:p>
+            <a:endParaRPr lang="en-US"/>
+          </a:p>
+        </p:txBody>
       </p:sp>
       <p:sp>
         <p:nvSpPr>
@@ -7882,6 +8011,13 @@
           </a:solidFill>
           <a:ln/>
         </p:spPr>
+        <p:txBody>
+          <a:bodyPr/>
+          <a:lstStyle/>
+          <a:p>
+            <a:endParaRPr lang="en-US"/>
+          </a:p>
+        </p:txBody>
       </p:sp>
       <p:sp>
         <p:nvSpPr>
@@ -7904,7 +8040,7 @@
           <a:bodyPr wrap="square" lIns="0" tIns="0" rIns="0" bIns="0" rtlCol="0" anchor="t"/>
           <a:lstStyle/>
           <a:p>
-            <a:pPr indent="0" marL="0">
+            <a:pPr marL="0" indent="0">
               <a:lnSpc>
                 <a:spcPct val="120000"/>
               </a:lnSpc>
@@ -7924,7 +8060,7 @@
             <a:endParaRPr lang="en-US" sz="1800" dirty="0"/>
           </a:p>
           <a:p>
-            <a:pPr indent="0" marL="0">
+            <a:pPr marL="0" indent="0">
               <a:lnSpc>
                 <a:spcPct val="120000"/>
               </a:lnSpc>
@@ -7944,7 +8080,7 @@
             <a:endParaRPr lang="en-US" sz="1800" dirty="0"/>
           </a:p>
           <a:p>
-            <a:pPr indent="0" marL="0">
+            <a:pPr marL="0" indent="0">
               <a:lnSpc>
                 <a:spcPct val="120000"/>
               </a:lnSpc>
@@ -7986,6 +8122,13 @@
           </a:solidFill>
           <a:ln/>
         </p:spPr>
+        <p:txBody>
+          <a:bodyPr/>
+          <a:lstStyle/>
+          <a:p>
+            <a:endParaRPr lang="en-US"/>
+          </a:p>
+        </p:txBody>
       </p:sp>
       <p:sp>
         <p:nvSpPr>
@@ -8008,7 +8151,7 @@
           <a:bodyPr wrap="square" lIns="0" tIns="0" rIns="0" bIns="0" rtlCol="0" anchor="t"/>
           <a:lstStyle/>
           <a:p>
-            <a:pPr indent="0" marL="0">
+            <a:pPr marL="0" indent="0">
               <a:lnSpc>
                 <a:spcPct val="125000"/>
               </a:lnSpc>
@@ -8050,6 +8193,13 @@
           </a:solidFill>
           <a:ln/>
         </p:spPr>
+        <p:txBody>
+          <a:bodyPr/>
+          <a:lstStyle/>
+          <a:p>
+            <a:endParaRPr lang="en-US"/>
+          </a:p>
+        </p:txBody>
       </p:sp>
       <p:sp>
         <p:nvSpPr>
@@ -8072,14 +8222,14 @@
           <a:bodyPr wrap="square" lIns="0" tIns="0" rIns="0" bIns="0" rtlCol="0" anchor="t"/>
           <a:lstStyle/>
           <a:p>
-            <a:pPr indent="0" marL="0">
+            <a:pPr marL="0" indent="0">
               <a:lnSpc>
                 <a:spcPct val="115000"/>
               </a:lnSpc>
               <a:buNone/>
             </a:pPr>
             <a:r>
-              <a:rPr lang="en-US" sz="2000" b="1" spc="30" kern="0" dirty="0">
+              <a:rPr lang="en-US" sz="2000" b="1" kern="0" spc="30" dirty="0">
                 <a:solidFill>
                   <a:srgbClr val="FFFFFF"/>
                 </a:solidFill>
@@ -8114,7 +8264,7 @@
           <a:bodyPr wrap="square" lIns="0" tIns="0" rIns="0" bIns="0" rtlCol="0" anchor="t"/>
           <a:lstStyle/>
           <a:p>
-            <a:pPr indent="0" marL="0">
+            <a:pPr marL="0" indent="0">
               <a:lnSpc>
                 <a:spcPct val="120000"/>
               </a:lnSpc>
@@ -8156,11 +8306,11 @@
           <a:bodyPr wrap="square" lIns="0" tIns="0" rIns="0" bIns="0" rtlCol="0" anchor="ctr"/>
           <a:lstStyle/>
           <a:p>
-            <a:pPr indent="0" marL="0">
-              <a:buNone/>
-            </a:pPr>
-            <a:r>
-              <a:rPr lang="en-US" sz="2000" spc="100" kern="0" dirty="0">
+            <a:pPr marL="0" indent="0">
+              <a:buNone/>
+            </a:pPr>
+            <a:r>
+              <a:rPr lang="en-US" sz="2000" kern="0" spc="100" dirty="0">
                 <a:solidFill>
                   <a:srgbClr val="5B6B84"/>
                 </a:solidFill>
@@ -8195,7 +8345,7 @@
           <a:bodyPr wrap="square" lIns="0" tIns="0" rIns="0" bIns="0" rtlCol="0" anchor="ctr"/>
           <a:lstStyle/>
           <a:p>
-            <a:pPr algn="r" indent="0" marL="0">
+            <a:pPr marL="0" indent="0" algn="r">
               <a:buNone/>
             </a:pPr>
             <a:r>
@@ -8215,14 +8365,14 @@
       </p:sp>
       <p:pic>
         <p:nvPicPr>
-          <p:cNvPr id="18" name="Image 1" descr="/home/user/BasicRobotLessons/docs/presentations/v3/template/assets/logo/team5010-logo-onwhite.png">    </p:cNvPr>
+          <p:cNvPr id="18" name="Image 1" descr="/home/user/BasicRobotLessons/docs/presentations/v3/template/assets/logo/team5010-logo-onwhite.png"/>
           <p:cNvPicPr>
             <a:picLocks noChangeAspect="1"/>
           </p:cNvPicPr>
           <p:nvPr/>
         </p:nvPicPr>
         <p:blipFill>
-          <a:blip r:embed="rId2"/>
+          <a:blip r:embed="rId4"/>
           <a:stretch>
             <a:fillRect/>
           </a:stretch>
@@ -8253,6 +8403,7 @@
         <a:solidFill>
           <a:srgbClr val="FFFFFF"/>
         </a:solidFill>
+        <a:effectLst/>
       </p:bgPr>
     </p:bg>
     <p:spTree>
@@ -8288,17 +8439,24 @@
           </a:solidFill>
           <a:ln/>
         </p:spPr>
+        <p:txBody>
+          <a:bodyPr/>
+          <a:lstStyle/>
+          <a:p>
+            <a:endParaRPr lang="en-US"/>
+          </a:p>
+        </p:txBody>
       </p:sp>
       <p:pic>
         <p:nvPicPr>
-          <p:cNvPr id="3" name="Image 0" descr="/home/user/BasicRobotLessons/docs/presentations/v3/template/assets/icons/sitemap_white.png">    </p:cNvPr>
+          <p:cNvPr id="3" name="Image 0" descr="/home/user/BasicRobotLessons/docs/presentations/v3/template/assets/icons/sitemap_white.png"/>
           <p:cNvPicPr>
             <a:picLocks noChangeAspect="1"/>
           </p:cNvPicPr>
           <p:nvPr/>
         </p:nvPicPr>
         <p:blipFill>
-          <a:blip r:embed="rId1"/>
+          <a:blip r:embed="rId3"/>
           <a:stretch>
             <a:fillRect/>
           </a:stretch>
@@ -8334,11 +8492,11 @@
           <a:bodyPr wrap="square" lIns="0" tIns="0" rIns="0" bIns="0" rtlCol="0" anchor="ctr"/>
           <a:lstStyle/>
           <a:p>
-            <a:pPr indent="0" marL="0">
-              <a:buNone/>
-            </a:pPr>
-            <a:r>
-              <a:rPr lang="en-US" sz="2000" b="1" spc="150" kern="0" dirty="0">
+            <a:pPr marL="0" indent="0">
+              <a:buNone/>
+            </a:pPr>
+            <a:r>
+              <a:rPr lang="en-US" sz="2000" b="1" kern="0" spc="150" dirty="0">
                 <a:solidFill>
                   <a:srgbClr val="FF5010"/>
                 </a:solidFill>
@@ -8373,7 +8531,7 @@
           <a:bodyPr wrap="square" lIns="0" tIns="0" rIns="0" bIns="0" rtlCol="0" anchor="ctr"/>
           <a:lstStyle/>
           <a:p>
-            <a:pPr indent="0" marL="0">
+            <a:pPr marL="0" indent="0">
               <a:buNone/>
             </a:pPr>
             <a:r>
@@ -8412,6 +8570,13 @@
           </a:solidFill>
           <a:ln/>
         </p:spPr>
+        <p:txBody>
+          <a:bodyPr/>
+          <a:lstStyle/>
+          <a:p>
+            <a:endParaRPr lang="en-US"/>
+          </a:p>
+        </p:txBody>
       </p:sp>
       <p:sp>
         <p:nvSpPr>
@@ -8434,11 +8599,11 @@
           <a:bodyPr wrap="square" lIns="0" tIns="0" rIns="0" bIns="0" rtlCol="0" anchor="ctr"/>
           <a:lstStyle/>
           <a:p>
-            <a:pPr indent="0" marL="0">
-              <a:buNone/>
-            </a:pPr>
-            <a:r>
-              <a:rPr lang="en-US" sz="2000" b="1" spc="50" kern="0" dirty="0">
+            <a:pPr marL="0" indent="0">
+              <a:buNone/>
+            </a:pPr>
+            <a:r>
+              <a:rPr lang="en-US" sz="2000" b="1" kern="0" spc="50" dirty="0">
                 <a:solidFill>
                   <a:srgbClr val="FF5010"/>
                 </a:solidFill>
@@ -8473,7 +8638,7 @@
           <a:bodyPr wrap="square" lIns="0" tIns="0" rIns="0" bIns="0" rtlCol="0" anchor="t"/>
           <a:lstStyle/>
           <a:p>
-            <a:pPr indent="0" marL="0">
+            <a:pPr marL="0" indent="0">
               <a:lnSpc>
                 <a:spcPct val="120000"/>
               </a:lnSpc>
@@ -8515,7 +8680,7 @@
           <a:bodyPr wrap="square" lIns="0" tIns="0" rIns="0" bIns="0" rtlCol="0" anchor="t"/>
           <a:lstStyle/>
           <a:p>
-            <a:pPr indent="0" marL="0">
+            <a:pPr marL="0" indent="0">
               <a:lnSpc>
                 <a:spcPct val="125000"/>
               </a:lnSpc>
@@ -8557,6 +8722,13 @@
           </a:solidFill>
           <a:ln/>
         </p:spPr>
+        <p:txBody>
+          <a:bodyPr/>
+          <a:lstStyle/>
+          <a:p>
+            <a:endParaRPr lang="en-US"/>
+          </a:p>
+        </p:txBody>
       </p:sp>
       <p:sp>
         <p:nvSpPr>
@@ -8579,11 +8751,11 @@
           <a:bodyPr wrap="square" lIns="0" tIns="0" rIns="0" bIns="0" rtlCol="0" anchor="ctr"/>
           <a:lstStyle/>
           <a:p>
-            <a:pPr indent="0" marL="0">
-              <a:buNone/>
-            </a:pPr>
-            <a:r>
-              <a:rPr lang="en-US" sz="2000" b="1" spc="50" kern="0" dirty="0">
+            <a:pPr marL="0" indent="0">
+              <a:buNone/>
+            </a:pPr>
+            <a:r>
+              <a:rPr lang="en-US" sz="2000" b="1" kern="0" spc="50" dirty="0">
                 <a:solidFill>
                   <a:srgbClr val="1B9AAA"/>
                 </a:solidFill>
@@ -8618,7 +8790,7 @@
           <a:bodyPr wrap="square" lIns="0" tIns="0" rIns="0" bIns="0" rtlCol="0" anchor="t"/>
           <a:lstStyle/>
           <a:p>
-            <a:pPr indent="0" marL="0">
+            <a:pPr marL="0" indent="0">
               <a:lnSpc>
                 <a:spcPct val="120000"/>
               </a:lnSpc>
@@ -8660,7 +8832,7 @@
           <a:bodyPr wrap="square" lIns="0" tIns="0" rIns="0" bIns="0" rtlCol="0" anchor="t"/>
           <a:lstStyle/>
           <a:p>
-            <a:pPr indent="0" marL="0">
+            <a:pPr marL="0" indent="0">
               <a:lnSpc>
                 <a:spcPct val="125000"/>
               </a:lnSpc>
@@ -8702,11 +8874,11 @@
           <a:bodyPr wrap="square" lIns="0" tIns="0" rIns="0" bIns="0" rtlCol="0" anchor="ctr"/>
           <a:lstStyle/>
           <a:p>
-            <a:pPr indent="0" marL="0">
-              <a:buNone/>
-            </a:pPr>
-            <a:r>
-              <a:rPr lang="en-US" sz="2000" spc="100" kern="0" dirty="0">
+            <a:pPr marL="0" indent="0">
+              <a:buNone/>
+            </a:pPr>
+            <a:r>
+              <a:rPr lang="en-US" sz="2000" kern="0" spc="100" dirty="0">
                 <a:solidFill>
                   <a:srgbClr val="5B6B84"/>
                 </a:solidFill>
@@ -8741,7 +8913,7 @@
           <a:bodyPr wrap="square" lIns="0" tIns="0" rIns="0" bIns="0" rtlCol="0" anchor="ctr"/>
           <a:lstStyle/>
           <a:p>
-            <a:pPr algn="r" indent="0" marL="0">
+            <a:pPr marL="0" indent="0" algn="r">
               <a:buNone/>
             </a:pPr>
             <a:r>
@@ -8761,14 +8933,14 @@
       </p:sp>
       <p:pic>
         <p:nvPicPr>
-          <p:cNvPr id="16" name="Image 1" descr="/home/user/BasicRobotLessons/docs/presentations/v3/template/assets/logo/team5010-logo-onwhite.png">    </p:cNvPr>
+          <p:cNvPr id="16" name="Image 1" descr="/home/user/BasicRobotLessons/docs/presentations/v3/template/assets/logo/team5010-logo-onwhite.png"/>
           <p:cNvPicPr>
             <a:picLocks noChangeAspect="1"/>
           </p:cNvPicPr>
           <p:nvPr/>
         </p:nvPicPr>
         <p:blipFill>
-          <a:blip r:embed="rId2"/>
+          <a:blip r:embed="rId4"/>
           <a:stretch>
             <a:fillRect/>
           </a:stretch>
@@ -8799,6 +8971,7 @@
         <a:solidFill>
           <a:srgbClr val="FFFFFF"/>
         </a:solidFill>
+        <a:effectLst/>
       </p:bgPr>
     </p:bg>
     <p:spTree>
@@ -8834,17 +9007,24 @@
           </a:solidFill>
           <a:ln/>
         </p:spPr>
+        <p:txBody>
+          <a:bodyPr/>
+          <a:lstStyle/>
+          <a:p>
+            <a:endParaRPr lang="en-US"/>
+          </a:p>
+        </p:txBody>
       </p:sp>
       <p:pic>
         <p:nvPicPr>
-          <p:cNvPr id="3" name="Image 0" descr="/home/user/BasicRobotLessons/docs/presentations/v3/template/assets/icons/checkcircle_white.png">    </p:cNvPr>
+          <p:cNvPr id="3" name="Image 0" descr="/home/user/BasicRobotLessons/docs/presentations/v3/template/assets/icons/checkcircle_white.png"/>
           <p:cNvPicPr>
             <a:picLocks noChangeAspect="1"/>
           </p:cNvPicPr>
           <p:nvPr/>
         </p:nvPicPr>
         <p:blipFill>
-          <a:blip r:embed="rId1"/>
+          <a:blip r:embed="rId3"/>
           <a:stretch>
             <a:fillRect/>
           </a:stretch>
@@ -8880,11 +9060,11 @@
           <a:bodyPr wrap="square" lIns="0" tIns="0" rIns="0" bIns="0" rtlCol="0" anchor="ctr"/>
           <a:lstStyle/>
           <a:p>
-            <a:pPr indent="0" marL="0">
-              <a:buNone/>
-            </a:pPr>
-            <a:r>
-              <a:rPr lang="en-US" sz="2000" b="1" spc="150" kern="0" dirty="0">
+            <a:pPr marL="0" indent="0">
+              <a:buNone/>
+            </a:pPr>
+            <a:r>
+              <a:rPr lang="en-US" sz="2000" b="1" kern="0" spc="150" dirty="0">
                 <a:solidFill>
                   <a:srgbClr val="FF5010"/>
                 </a:solidFill>
@@ -8919,7 +9099,7 @@
           <a:bodyPr wrap="square" lIns="0" tIns="0" rIns="0" bIns="0" rtlCol="0" anchor="ctr"/>
           <a:lstStyle/>
           <a:p>
-            <a:pPr indent="0" marL="0">
+            <a:pPr marL="0" indent="0">
               <a:buNone/>
             </a:pPr>
             <a:r>
@@ -8958,13 +9138,20 @@
           </a:solidFill>
           <a:ln/>
           <a:effectLst>
-            <a:outerShdw sx="100000" sy="100000" kx="0" ky="0" algn="bl" rotWithShape="0" blurRad="101600" dist="38100" dir="5400000">
+            <a:outerShdw blurRad="101600" dist="38100" dir="5400000" algn="bl" rotWithShape="0">
               <a:srgbClr val="0B1F3A">
                 <a:alpha val="35000"/>
               </a:srgbClr>
             </a:outerShdw>
           </a:effectLst>
         </p:spPr>
+        <p:txBody>
+          <a:bodyPr/>
+          <a:lstStyle/>
+          <a:p>
+            <a:endParaRPr lang="en-US"/>
+          </a:p>
+        </p:txBody>
       </p:sp>
       <p:sp>
         <p:nvSpPr>
@@ -8985,6 +9172,13 @@
           </a:solidFill>
           <a:ln/>
         </p:spPr>
+        <p:txBody>
+          <a:bodyPr/>
+          <a:lstStyle/>
+          <a:p>
+            <a:endParaRPr lang="en-US"/>
+          </a:p>
+        </p:txBody>
       </p:sp>
       <p:sp>
         <p:nvSpPr>
@@ -9005,6 +9199,13 @@
           </a:solidFill>
           <a:ln/>
         </p:spPr>
+        <p:txBody>
+          <a:bodyPr/>
+          <a:lstStyle/>
+          <a:p>
+            <a:endParaRPr lang="en-US"/>
+          </a:p>
+        </p:txBody>
       </p:sp>
       <p:sp>
         <p:nvSpPr>
@@ -9025,6 +9226,13 @@
           </a:solidFill>
           <a:ln/>
         </p:spPr>
+        <p:txBody>
+          <a:bodyPr/>
+          <a:lstStyle/>
+          <a:p>
+            <a:endParaRPr lang="en-US"/>
+          </a:p>
+        </p:txBody>
       </p:sp>
       <p:sp>
         <p:nvSpPr>
@@ -9047,7 +9255,7 @@
           <a:bodyPr wrap="square" lIns="0" tIns="0" rIns="0" bIns="0" rtlCol="0" anchor="t"/>
           <a:lstStyle/>
           <a:p>
-            <a:pPr indent="0" marL="0">
+            <a:pPr marL="0" indent="0">
               <a:lnSpc>
                 <a:spcPct val="120000"/>
               </a:lnSpc>
@@ -9067,7 +9275,7 @@
             <a:endParaRPr lang="en-US" sz="1700" dirty="0"/>
           </a:p>
           <a:p>
-            <a:pPr indent="0" marL="0">
+            <a:pPr marL="0" indent="0">
               <a:lnSpc>
                 <a:spcPct val="120000"/>
               </a:lnSpc>
@@ -9087,7 +9295,7 @@
             <a:endParaRPr lang="en-US" sz="1700" dirty="0"/>
           </a:p>
           <a:p>
-            <a:pPr indent="0" marL="0">
+            <a:pPr marL="0" indent="0">
               <a:lnSpc>
                 <a:spcPct val="120000"/>
               </a:lnSpc>
@@ -9129,13 +9337,20 @@
           </a:solidFill>
           <a:ln/>
           <a:effectLst>
-            <a:outerShdw sx="100000" sy="100000" kx="0" ky="0" algn="bl" rotWithShape="0" blurRad="101600" dist="38100" dir="5400000">
+            <a:outerShdw blurRad="101600" dist="38100" dir="5400000" algn="bl" rotWithShape="0">
               <a:srgbClr val="0B1F3A">
                 <a:alpha val="35000"/>
               </a:srgbClr>
             </a:outerShdw>
           </a:effectLst>
         </p:spPr>
+        <p:txBody>
+          <a:bodyPr/>
+          <a:lstStyle/>
+          <a:p>
+            <a:endParaRPr lang="en-US"/>
+          </a:p>
+        </p:txBody>
       </p:sp>
       <p:sp>
         <p:nvSpPr>
@@ -9156,6 +9371,13 @@
           </a:solidFill>
           <a:ln/>
         </p:spPr>
+        <p:txBody>
+          <a:bodyPr/>
+          <a:lstStyle/>
+          <a:p>
+            <a:endParaRPr lang="en-US"/>
+          </a:p>
+        </p:txBody>
       </p:sp>
       <p:sp>
         <p:nvSpPr>
@@ -9176,6 +9398,13 @@
           </a:solidFill>
           <a:ln/>
         </p:spPr>
+        <p:txBody>
+          <a:bodyPr/>
+          <a:lstStyle/>
+          <a:p>
+            <a:endParaRPr lang="en-US"/>
+          </a:p>
+        </p:txBody>
       </p:sp>
       <p:sp>
         <p:nvSpPr>
@@ -9196,6 +9425,13 @@
           </a:solidFill>
           <a:ln/>
         </p:spPr>
+        <p:txBody>
+          <a:bodyPr/>
+          <a:lstStyle/>
+          <a:p>
+            <a:endParaRPr lang="en-US"/>
+          </a:p>
+        </p:txBody>
       </p:sp>
       <p:sp>
         <p:nvSpPr>
@@ -9218,7 +9454,7 @@
           <a:bodyPr wrap="square" lIns="0" tIns="0" rIns="0" bIns="0" rtlCol="0" anchor="t"/>
           <a:lstStyle/>
           <a:p>
-            <a:pPr indent="0" marL="0">
+            <a:pPr marL="0" indent="0">
               <a:lnSpc>
                 <a:spcPct val="120000"/>
               </a:lnSpc>
@@ -9238,7 +9474,7 @@
             <a:endParaRPr lang="en-US" sz="1700" dirty="0"/>
           </a:p>
           <a:p>
-            <a:pPr indent="0" marL="0">
+            <a:pPr marL="0" indent="0">
               <a:lnSpc>
                 <a:spcPct val="120000"/>
               </a:lnSpc>
@@ -9258,7 +9494,7 @@
             <a:endParaRPr lang="en-US" sz="1700" dirty="0"/>
           </a:p>
           <a:p>
-            <a:pPr indent="0" marL="0">
+            <a:pPr marL="0" indent="0">
               <a:lnSpc>
                 <a:spcPct val="120000"/>
               </a:lnSpc>
@@ -9278,7 +9514,7 @@
             <a:endParaRPr lang="en-US" sz="1700" dirty="0"/>
           </a:p>
           <a:p>
-            <a:pPr indent="0" marL="0">
+            <a:pPr marL="0" indent="0">
               <a:lnSpc>
                 <a:spcPct val="120000"/>
               </a:lnSpc>
@@ -9320,6 +9556,13 @@
           </a:solidFill>
           <a:ln/>
         </p:spPr>
+        <p:txBody>
+          <a:bodyPr/>
+          <a:lstStyle/>
+          <a:p>
+            <a:endParaRPr lang="en-US"/>
+          </a:p>
+        </p:txBody>
       </p:sp>
       <p:sp>
         <p:nvSpPr>
@@ -9342,7 +9585,7 @@
           <a:bodyPr wrap="square" lIns="0" tIns="0" rIns="0" bIns="0" rtlCol="0" anchor="t"/>
           <a:lstStyle/>
           <a:p>
-            <a:pPr indent="0" marL="0">
+            <a:pPr marL="0" indent="0">
               <a:lnSpc>
                 <a:spcPct val="120000"/>
               </a:lnSpc>
@@ -9384,7 +9627,7 @@
           <a:bodyPr wrap="square" lIns="0" tIns="0" rIns="0" bIns="0" rtlCol="0" anchor="t"/>
           <a:lstStyle/>
           <a:p>
-            <a:pPr indent="0" marL="0">
+            <a:pPr marL="0" indent="0">
               <a:lnSpc>
                 <a:spcPct val="125000"/>
               </a:lnSpc>
@@ -9426,11 +9669,11 @@
           <a:bodyPr wrap="square" lIns="0" tIns="0" rIns="0" bIns="0" rtlCol="0" anchor="ctr"/>
           <a:lstStyle/>
           <a:p>
-            <a:pPr indent="0" marL="0">
-              <a:buNone/>
-            </a:pPr>
-            <a:r>
-              <a:rPr lang="en-US" sz="2000" spc="100" kern="0" dirty="0">
+            <a:pPr marL="0" indent="0">
+              <a:buNone/>
+            </a:pPr>
+            <a:r>
+              <a:rPr lang="en-US" sz="2000" kern="0" spc="100" dirty="0">
                 <a:solidFill>
                   <a:srgbClr val="5B6B84"/>
                 </a:solidFill>
@@ -9465,7 +9708,7 @@
           <a:bodyPr wrap="square" lIns="0" tIns="0" rIns="0" bIns="0" rtlCol="0" anchor="ctr"/>
           <a:lstStyle/>
           <a:p>
-            <a:pPr algn="r" indent="0" marL="0">
+            <a:pPr marL="0" indent="0" algn="r">
               <a:buNone/>
             </a:pPr>
             <a:r>
@@ -9485,14 +9728,14 @@
       </p:sp>
       <p:pic>
         <p:nvPicPr>
-          <p:cNvPr id="21" name="Image 1" descr="/home/user/BasicRobotLessons/docs/presentations/v3/template/assets/logo/team5010-logo-onwhite.png">    </p:cNvPr>
+          <p:cNvPr id="21" name="Image 1" descr="/home/user/BasicRobotLessons/docs/presentations/v3/template/assets/logo/team5010-logo-onwhite.png"/>
           <p:cNvPicPr>
             <a:picLocks noChangeAspect="1"/>
           </p:cNvPicPr>
           <p:nvPr/>
         </p:nvPicPr>
         <p:blipFill>
-          <a:blip r:embed="rId2"/>
+          <a:blip r:embed="rId4"/>
           <a:stretch>
             <a:fillRect/>
           </a:stretch>
@@ -9523,6 +9766,7 @@
         <a:solidFill>
           <a:srgbClr val="FFFFFF"/>
         </a:solidFill>
+        <a:effectLst/>
       </p:bgPr>
     </p:bg>
     <p:spTree>
@@ -9558,17 +9802,24 @@
           </a:solidFill>
           <a:ln/>
         </p:spPr>
+        <p:txBody>
+          <a:bodyPr/>
+          <a:lstStyle/>
+          <a:p>
+            <a:endParaRPr lang="en-US"/>
+          </a:p>
+        </p:txBody>
       </p:sp>
       <p:pic>
         <p:nvPicPr>
-          <p:cNvPr id="3" name="Image 0" descr="/home/user/BasicRobotLessons/docs/presentations/v3/template/assets/icons/key_white.png">    </p:cNvPr>
+          <p:cNvPr id="3" name="Image 0" descr="/home/user/BasicRobotLessons/docs/presentations/v3/template/assets/icons/key_white.png"/>
           <p:cNvPicPr>
             <a:picLocks noChangeAspect="1"/>
           </p:cNvPicPr>
           <p:nvPr/>
         </p:nvPicPr>
         <p:blipFill>
-          <a:blip r:embed="rId1"/>
+          <a:blip r:embed="rId3"/>
           <a:stretch>
             <a:fillRect/>
           </a:stretch>
@@ -9604,11 +9855,11 @@
           <a:bodyPr wrap="square" lIns="0" tIns="0" rIns="0" bIns="0" rtlCol="0" anchor="ctr"/>
           <a:lstStyle/>
           <a:p>
-            <a:pPr indent="0" marL="0">
-              <a:buNone/>
-            </a:pPr>
-            <a:r>
-              <a:rPr lang="en-US" sz="2000" b="1" spc="150" kern="0" dirty="0">
+            <a:pPr marL="0" indent="0">
+              <a:buNone/>
+            </a:pPr>
+            <a:r>
+              <a:rPr lang="en-US" sz="2000" b="1" kern="0" spc="150" dirty="0">
                 <a:solidFill>
                   <a:srgbClr val="FF5010"/>
                 </a:solidFill>
@@ -9643,7 +9894,7 @@
           <a:bodyPr wrap="square" lIns="0" tIns="0" rIns="0" bIns="0" rtlCol="0" anchor="ctr"/>
           <a:lstStyle/>
           <a:p>
-            <a:pPr indent="0" marL="0">
+            <a:pPr marL="0" indent="0">
               <a:buNone/>
             </a:pPr>
             <a:r>
@@ -9682,13 +9933,20 @@
           </a:solidFill>
           <a:ln/>
           <a:effectLst>
-            <a:outerShdw sx="100000" sy="100000" kx="0" ky="0" algn="bl" rotWithShape="0" blurRad="101600" dist="38100" dir="5400000">
+            <a:outerShdw blurRad="101600" dist="38100" dir="5400000" algn="bl" rotWithShape="0">
               <a:srgbClr val="0B1F3A">
                 <a:alpha val="35000"/>
               </a:srgbClr>
             </a:outerShdw>
           </a:effectLst>
         </p:spPr>
+        <p:txBody>
+          <a:bodyPr/>
+          <a:lstStyle/>
+          <a:p>
+            <a:endParaRPr lang="en-US"/>
+          </a:p>
+        </p:txBody>
       </p:sp>
       <p:sp>
         <p:nvSpPr>
@@ -9709,6 +9967,13 @@
           </a:solidFill>
           <a:ln/>
         </p:spPr>
+        <p:txBody>
+          <a:bodyPr/>
+          <a:lstStyle/>
+          <a:p>
+            <a:endParaRPr lang="en-US"/>
+          </a:p>
+        </p:txBody>
       </p:sp>
       <p:sp>
         <p:nvSpPr>
@@ -9729,6 +9994,13 @@
           </a:solidFill>
           <a:ln/>
         </p:spPr>
+        <p:txBody>
+          <a:bodyPr/>
+          <a:lstStyle/>
+          <a:p>
+            <a:endParaRPr lang="en-US"/>
+          </a:p>
+        </p:txBody>
       </p:sp>
       <p:sp>
         <p:nvSpPr>
@@ -9749,6 +10021,13 @@
           </a:solidFill>
           <a:ln/>
         </p:spPr>
+        <p:txBody>
+          <a:bodyPr/>
+          <a:lstStyle/>
+          <a:p>
+            <a:endParaRPr lang="en-US"/>
+          </a:p>
+        </p:txBody>
       </p:sp>
       <p:sp>
         <p:nvSpPr>
@@ -9771,7 +10050,7 @@
           <a:bodyPr wrap="square" lIns="0" tIns="0" rIns="0" bIns="0" rtlCol="0" anchor="t"/>
           <a:lstStyle/>
           <a:p>
-            <a:pPr indent="0" marL="0">
+            <a:pPr marL="0" indent="0">
               <a:lnSpc>
                 <a:spcPct val="120000"/>
               </a:lnSpc>
@@ -9813,7 +10092,7 @@
           <a:bodyPr wrap="square" lIns="0" tIns="0" rIns="0" bIns="0" rtlCol="0" anchor="t"/>
           <a:lstStyle/>
           <a:p>
-            <a:pPr indent="0" marL="0">
+            <a:pPr marL="0" indent="0">
               <a:lnSpc>
                 <a:spcPct val="125000"/>
               </a:lnSpc>
@@ -9855,6 +10134,13 @@
           </a:solidFill>
           <a:ln/>
         </p:spPr>
+        <p:txBody>
+          <a:bodyPr/>
+          <a:lstStyle/>
+          <a:p>
+            <a:endParaRPr lang="en-US"/>
+          </a:p>
+        </p:txBody>
       </p:sp>
       <p:sp>
         <p:nvSpPr>
@@ -9877,11 +10163,11 @@
           <a:bodyPr wrap="square" lIns="0" tIns="0" rIns="0" bIns="0" rtlCol="0" anchor="ctr"/>
           <a:lstStyle/>
           <a:p>
-            <a:pPr indent="0" marL="0">
-              <a:buNone/>
-            </a:pPr>
-            <a:r>
-              <a:rPr lang="en-US" sz="2000" b="1" spc="50" kern="0" dirty="0">
+            <a:pPr marL="0" indent="0">
+              <a:buNone/>
+            </a:pPr>
+            <a:r>
+              <a:rPr lang="en-US" sz="2000" b="1" kern="0" spc="50" dirty="0">
                 <a:solidFill>
                   <a:srgbClr val="1B9AAA"/>
                 </a:solidFill>
@@ -9916,7 +10202,7 @@
           <a:bodyPr wrap="square" lIns="0" tIns="0" rIns="0" bIns="0" rtlCol="0" anchor="t"/>
           <a:lstStyle/>
           <a:p>
-            <a:pPr indent="0" marL="0">
+            <a:pPr marL="0" indent="0">
               <a:lnSpc>
                 <a:spcPct val="120000"/>
               </a:lnSpc>
@@ -9931,7 +10217,29 @@
                 <a:ea typeface="Cambria" pitchFamily="34" charset="-122"/>
                 <a:cs typeface="Cambria" pitchFamily="34" charset="-120"/>
               </a:rPr>
-              <a:t>GitHub.com → HTTPS → authenticate Git with your GitHub credentials → log in with a web browser.</a:t>
+              <a:t>https://github.</a:t>
+            </a:r>
+            <a:r>
+              <a:rPr lang="en-US" sz="2100" b="1">
+                <a:solidFill>
+                  <a:srgbClr val="FFFFFF"/>
+                </a:solidFill>
+                <a:latin typeface="Cambria" pitchFamily="34" charset="0"/>
+                <a:ea typeface="Cambria" pitchFamily="34" charset="-122"/>
+                <a:cs typeface="Cambria" pitchFamily="34" charset="-120"/>
+              </a:rPr>
+              <a:t>com → </a:t>
+            </a:r>
+            <a:r>
+              <a:rPr lang="en-US" sz="2100" b="1" dirty="0">
+                <a:solidFill>
+                  <a:srgbClr val="FFFFFF"/>
+                </a:solidFill>
+                <a:latin typeface="Cambria" pitchFamily="34" charset="0"/>
+                <a:ea typeface="Cambria" pitchFamily="34" charset="-122"/>
+                <a:cs typeface="Cambria" pitchFamily="34" charset="-120"/>
+              </a:rPr>
+              <a:t>authenticate Git with your GitHub credentials → log in with a web browser.</a:t>
             </a:r>
             <a:endParaRPr lang="en-US" sz="2100" dirty="0"/>
           </a:p>
@@ -9958,7 +10266,7 @@
           <a:bodyPr wrap="square" lIns="0" tIns="0" rIns="0" bIns="0" rtlCol="0" anchor="t"/>
           <a:lstStyle/>
           <a:p>
-            <a:pPr indent="0" marL="0">
+            <a:pPr marL="0" indent="0">
               <a:lnSpc>
                 <a:spcPct val="125000"/>
               </a:lnSpc>
@@ -10000,11 +10308,11 @@
           <a:bodyPr wrap="square" lIns="0" tIns="0" rIns="0" bIns="0" rtlCol="0" anchor="ctr"/>
           <a:lstStyle/>
           <a:p>
-            <a:pPr indent="0" marL="0">
-              <a:buNone/>
-            </a:pPr>
-            <a:r>
-              <a:rPr lang="en-US" sz="2000" spc="100" kern="0" dirty="0">
+            <a:pPr marL="0" indent="0">
+              <a:buNone/>
+            </a:pPr>
+            <a:r>
+              <a:rPr lang="en-US" sz="2000" kern="0" spc="100" dirty="0">
                 <a:solidFill>
                   <a:srgbClr val="5B6B84"/>
                 </a:solidFill>
@@ -10039,7 +10347,7 @@
           <a:bodyPr wrap="square" lIns="0" tIns="0" rIns="0" bIns="0" rtlCol="0" anchor="ctr"/>
           <a:lstStyle/>
           <a:p>
-            <a:pPr algn="r" indent="0" marL="0">
+            <a:pPr marL="0" indent="0" algn="r">
               <a:buNone/>
             </a:pPr>
             <a:r>
@@ -10059,14 +10367,14 @@
       </p:sp>
       <p:pic>
         <p:nvPicPr>
-          <p:cNvPr id="18" name="Image 1" descr="/home/user/BasicRobotLessons/docs/presentations/v3/template/assets/logo/team5010-logo-onwhite.png">    </p:cNvPr>
+          <p:cNvPr id="18" name="Image 1" descr="/home/user/BasicRobotLessons/docs/presentations/v3/template/assets/logo/team5010-logo-onwhite.png"/>
           <p:cNvPicPr>
             <a:picLocks noChangeAspect="1"/>
           </p:cNvPicPr>
           <p:nvPr/>
         </p:nvPicPr>
         <p:blipFill>
-          <a:blip r:embed="rId2"/>
+          <a:blip r:embed="rId4"/>
           <a:stretch>
             <a:fillRect/>
           </a:stretch>
@@ -10382,4 +10690,319 @@
     </a:ext>
   </a:extLst>
 </a:theme>
+</file>
+
+<file path=ppt/theme/theme2.xml><?xml version="1.0" encoding="utf-8"?>
+<a:theme xmlns:a="http://schemas.openxmlformats.org/drawingml/2006/main" name="Office Theme">
+  <a:themeElements>
+    <a:clrScheme name="Office">
+      <a:dk1>
+        <a:sysClr val="windowText" lastClr="000000"/>
+      </a:dk1>
+      <a:lt1>
+        <a:sysClr val="window" lastClr="FFFFFF"/>
+      </a:lt1>
+      <a:dk2>
+        <a:srgbClr val="0E2841"/>
+      </a:dk2>
+      <a:lt2>
+        <a:srgbClr val="E8E8E8"/>
+      </a:lt2>
+      <a:accent1>
+        <a:srgbClr val="156082"/>
+      </a:accent1>
+      <a:accent2>
+        <a:srgbClr val="E97132"/>
+      </a:accent2>
+      <a:accent3>
+        <a:srgbClr val="196B24"/>
+      </a:accent3>
+      <a:accent4>
+        <a:srgbClr val="0F9ED5"/>
+      </a:accent4>
+      <a:accent5>
+        <a:srgbClr val="A02B93"/>
+      </a:accent5>
+      <a:accent6>
+        <a:srgbClr val="4EA72E"/>
+      </a:accent6>
+      <a:hlink>
+        <a:srgbClr val="467886"/>
+      </a:hlink>
+      <a:folHlink>
+        <a:srgbClr val="96607D"/>
+      </a:folHlink>
+    </a:clrScheme>
+    <a:fontScheme name="Office">
+      <a:majorFont>
+        <a:latin typeface="Aptos Display" panose="02110004020202020204"/>
+        <a:ea typeface=""/>
+        <a:cs typeface=""/>
+        <a:font script="Jpan" typeface="游ゴシック Light"/>
+        <a:font script="Hang" typeface="맑은 고딕"/>
+        <a:font script="Hans" typeface="等线 Light"/>
+        <a:font script="Hant" typeface="新細明體"/>
+        <a:font script="Arab" typeface="Times New Roman"/>
+        <a:font script="Hebr" typeface="Times New Roman"/>
+        <a:font script="Thai" typeface="Angsana New"/>
+        <a:font script="Ethi" typeface="Nyala"/>
+        <a:font script="Beng" typeface="Vrinda"/>
+        <a:font script="Gujr" typeface="Shruti"/>
+        <a:font script="Khmr" typeface="MoolBoran"/>
+        <a:font script="Knda" typeface="Tunga"/>
+        <a:font script="Guru" typeface="Raavi"/>
+        <a:font script="Cans" typeface="Euphemia"/>
+        <a:font script="Cher" typeface="Plantagenet Cherokee"/>
+        <a:font script="Yiii" typeface="Microsoft Yi Baiti"/>
+        <a:font script="Tibt" typeface="Microsoft Himalaya"/>
+        <a:font script="Thaa" typeface="MV Boli"/>
+        <a:font script="Deva" typeface="Mangal"/>
+        <a:font script="Telu" typeface="Gautami"/>
+        <a:font script="Taml" typeface="Latha"/>
+        <a:font script="Syrc" typeface="Estrangelo Edessa"/>
+        <a:font script="Orya" typeface="Kalinga"/>
+        <a:font script="Mlym" typeface="Kartika"/>
+        <a:font script="Laoo" typeface="DokChampa"/>
+        <a:font script="Sinh" typeface="Iskoola Pota"/>
+        <a:font script="Mong" typeface="Mongolian Baiti"/>
+        <a:font script="Viet" typeface="Times New Roman"/>
+        <a:font script="Uigh" typeface="Microsoft Uighur"/>
+        <a:font script="Geor" typeface="Sylfaen"/>
+        <a:font script="Armn" typeface="Arial"/>
+        <a:font script="Bugi" typeface="Leelawadee UI"/>
+        <a:font script="Bopo" typeface="Microsoft JhengHei"/>
+        <a:font script="Java" typeface="Javanese Text"/>
+        <a:font script="Lisu" typeface="Segoe UI"/>
+        <a:font script="Mymr" typeface="Myanmar Text"/>
+        <a:font script="Nkoo" typeface="Ebrima"/>
+        <a:font script="Olck" typeface="Nirmala UI"/>
+        <a:font script="Osma" typeface="Ebrima"/>
+        <a:font script="Phag" typeface="Phagspa"/>
+        <a:font script="Syrn" typeface="Estrangelo Edessa"/>
+        <a:font script="Syrj" typeface="Estrangelo Edessa"/>
+        <a:font script="Syre" typeface="Estrangelo Edessa"/>
+        <a:font script="Sora" typeface="Nirmala UI"/>
+        <a:font script="Tale" typeface="Microsoft Tai Le"/>
+        <a:font script="Talu" typeface="Microsoft New Tai Lue"/>
+        <a:font script="Tfng" typeface="Ebrima"/>
+      </a:majorFont>
+      <a:minorFont>
+        <a:latin typeface="Aptos" panose="02110004020202020204"/>
+        <a:ea typeface=""/>
+        <a:cs typeface=""/>
+        <a:font script="Jpan" typeface="游ゴシック"/>
+        <a:font script="Hang" typeface="맑은 고딕"/>
+        <a:font script="Hans" typeface="等线"/>
+        <a:font script="Hant" typeface="新細明體"/>
+        <a:font script="Arab" typeface="Arial"/>
+        <a:font script="Hebr" typeface="Arial"/>
+        <a:font script="Thai" typeface="Cordia New"/>
+        <a:font script="Ethi" typeface="Nyala"/>
+        <a:font script="Beng" typeface="Vrinda"/>
+        <a:font script="Gujr" typeface="Shruti"/>
+        <a:font script="Khmr" typeface="DaunPenh"/>
+        <a:font script="Knda" typeface="Tunga"/>
+        <a:font script="Guru" typeface="Raavi"/>
+        <a:font script="Cans" typeface="Euphemia"/>
+        <a:font script="Cher" typeface="Plantagenet Cherokee"/>
+        <a:font script="Yiii" typeface="Microsoft Yi Baiti"/>
+        <a:font script="Tibt" typeface="Microsoft Himalaya"/>
+        <a:font script="Thaa" typeface="MV Boli"/>
+        <a:font script="Deva" typeface="Mangal"/>
+        <a:font script="Telu" typeface="Gautami"/>
+        <a:font script="Taml" typeface="Latha"/>
+        <a:font script="Syrc" typeface="Estrangelo Edessa"/>
+        <a:font script="Orya" typeface="Kalinga"/>
+        <a:font script="Mlym" typeface="Kartika"/>
+        <a:font script="Laoo" typeface="DokChampa"/>
+        <a:font script="Sinh" typeface="Iskoola Pota"/>
+        <a:font script="Mong" typeface="Mongolian Baiti"/>
+        <a:font script="Viet" typeface="Arial"/>
+        <a:font script="Uigh" typeface="Microsoft Uighur"/>
+        <a:font script="Geor" typeface="Sylfaen"/>
+        <a:font script="Armn" typeface="Arial"/>
+        <a:font script="Bugi" typeface="Leelawadee UI"/>
+        <a:font script="Bopo" typeface="Microsoft JhengHei"/>
+        <a:font script="Java" typeface="Javanese Text"/>
+        <a:font script="Lisu" typeface="Segoe UI"/>
+        <a:font script="Mymr" typeface="Myanmar Text"/>
+        <a:font script="Nkoo" typeface="Ebrima"/>
+        <a:font script="Olck" typeface="Nirmala UI"/>
+        <a:font script="Osma" typeface="Ebrima"/>
+        <a:font script="Phag" typeface="Phagspa"/>
+        <a:font script="Syrn" typeface="Estrangelo Edessa"/>
+        <a:font script="Syrj" typeface="Estrangelo Edessa"/>
+        <a:font script="Syre" typeface="Estrangelo Edessa"/>
+        <a:font script="Sora" typeface="Nirmala UI"/>
+        <a:font script="Tale" typeface="Microsoft Tai Le"/>
+        <a:font script="Talu" typeface="Microsoft New Tai Lue"/>
+        <a:font script="Tfng" typeface="Ebrima"/>
+      </a:minorFont>
+    </a:fontScheme>
+    <a:fmtScheme name="Office">
+      <a:fillStyleLst>
+        <a:solidFill>
+          <a:schemeClr val="phClr"/>
+        </a:solidFill>
+        <a:gradFill rotWithShape="1">
+          <a:gsLst>
+            <a:gs pos="0">
+              <a:schemeClr val="phClr">
+                <a:lumMod val="110000"/>
+                <a:satMod val="105000"/>
+                <a:tint val="67000"/>
+              </a:schemeClr>
+            </a:gs>
+            <a:gs pos="50000">
+              <a:schemeClr val="phClr">
+                <a:lumMod val="105000"/>
+                <a:satMod val="103000"/>
+                <a:tint val="73000"/>
+              </a:schemeClr>
+            </a:gs>
+            <a:gs pos="100000">
+              <a:schemeClr val="phClr">
+                <a:lumMod val="105000"/>
+                <a:satMod val="109000"/>
+                <a:tint val="81000"/>
+              </a:schemeClr>
+            </a:gs>
+          </a:gsLst>
+          <a:lin ang="5400000" scaled="0"/>
+        </a:gradFill>
+        <a:gradFill rotWithShape="1">
+          <a:gsLst>
+            <a:gs pos="0">
+              <a:schemeClr val="phClr">
+                <a:satMod val="103000"/>
+                <a:lumMod val="102000"/>
+                <a:tint val="94000"/>
+              </a:schemeClr>
+            </a:gs>
+            <a:gs pos="50000">
+              <a:schemeClr val="phClr">
+                <a:satMod val="110000"/>
+                <a:lumMod val="100000"/>
+                <a:shade val="100000"/>
+              </a:schemeClr>
+            </a:gs>
+            <a:gs pos="100000">
+              <a:schemeClr val="phClr">
+                <a:lumMod val="99000"/>
+                <a:satMod val="120000"/>
+                <a:shade val="78000"/>
+              </a:schemeClr>
+            </a:gs>
+          </a:gsLst>
+          <a:lin ang="5400000" scaled="0"/>
+        </a:gradFill>
+      </a:fillStyleLst>
+      <a:lnStyleLst>
+        <a:ln w="12700" cap="flat" cmpd="sng" algn="ctr">
+          <a:solidFill>
+            <a:schemeClr val="phClr"/>
+          </a:solidFill>
+          <a:prstDash val="solid"/>
+          <a:miter lim="800000"/>
+        </a:ln>
+        <a:ln w="19050" cap="flat" cmpd="sng" algn="ctr">
+          <a:solidFill>
+            <a:schemeClr val="phClr"/>
+          </a:solidFill>
+          <a:prstDash val="solid"/>
+          <a:miter lim="800000"/>
+        </a:ln>
+        <a:ln w="25400" cap="flat" cmpd="sng" algn="ctr">
+          <a:solidFill>
+            <a:schemeClr val="phClr"/>
+          </a:solidFill>
+          <a:prstDash val="solid"/>
+          <a:miter lim="800000"/>
+        </a:ln>
+      </a:lnStyleLst>
+      <a:effectStyleLst>
+        <a:effectStyle>
+          <a:effectLst/>
+        </a:effectStyle>
+        <a:effectStyle>
+          <a:effectLst/>
+        </a:effectStyle>
+        <a:effectStyle>
+          <a:effectLst>
+            <a:outerShdw blurRad="57150" dist="19050" dir="5400000" algn="ctr" rotWithShape="0">
+              <a:srgbClr val="000000">
+                <a:alpha val="63000"/>
+              </a:srgbClr>
+            </a:outerShdw>
+          </a:effectLst>
+        </a:effectStyle>
+      </a:effectStyleLst>
+      <a:bgFillStyleLst>
+        <a:solidFill>
+          <a:schemeClr val="phClr"/>
+        </a:solidFill>
+        <a:solidFill>
+          <a:schemeClr val="phClr">
+            <a:tint val="95000"/>
+            <a:satMod val="170000"/>
+          </a:schemeClr>
+        </a:solidFill>
+        <a:gradFill rotWithShape="1">
+          <a:gsLst>
+            <a:gs pos="0">
+              <a:schemeClr val="phClr">
+                <a:tint val="93000"/>
+                <a:satMod val="150000"/>
+                <a:shade val="98000"/>
+                <a:lumMod val="102000"/>
+              </a:schemeClr>
+            </a:gs>
+            <a:gs pos="50000">
+              <a:schemeClr val="phClr">
+                <a:tint val="98000"/>
+                <a:satMod val="130000"/>
+                <a:shade val="90000"/>
+                <a:lumMod val="103000"/>
+              </a:schemeClr>
+            </a:gs>
+            <a:gs pos="100000">
+              <a:schemeClr val="phClr">
+                <a:shade val="63000"/>
+                <a:satMod val="120000"/>
+              </a:schemeClr>
+            </a:gs>
+          </a:gsLst>
+          <a:lin ang="5400000" scaled="0"/>
+        </a:gradFill>
+      </a:bgFillStyleLst>
+    </a:fmtScheme>
+  </a:themeElements>
+  <a:objectDefaults>
+    <a:lnDef>
+      <a:spPr/>
+      <a:bodyPr/>
+      <a:lstStyle/>
+      <a:style>
+        <a:lnRef idx="2">
+          <a:schemeClr val="accent1"/>
+        </a:lnRef>
+        <a:fillRef idx="0">
+          <a:schemeClr val="accent1"/>
+        </a:fillRef>
+        <a:effectRef idx="1">
+          <a:schemeClr val="accent1"/>
+        </a:effectRef>
+        <a:fontRef idx="minor">
+          <a:schemeClr val="tx1"/>
+        </a:fontRef>
+      </a:style>
+    </a:lnDef>
+  </a:objectDefaults>
+  <a:extraClrSchemeLst/>
+  <a:extLst>
+    <a:ext uri="{05A4C25C-085E-4340-85A3-A5531E510DB2}">
+      <thm15:themeFamily xmlns:thm15="http://schemas.microsoft.com/office/thememl/2012/main" name="Office Theme" id="{2E142A2C-CD16-42D6-873A-C26D2A0506FA}" vid="{1BDDFF52-6CD6-40A5-AB3C-68EB2F1E4D0A}"/>
+    </a:ext>
+  </a:extLst>
+</a:theme>
 </file>
</xml_diff>